<commit_message>
Slides: shorten sd-04-036 lines to the 10-word budget
Co-Authored-By: Claude Opus 5.5 <noreply@anthropic.com>
Claude-Session: https://claude.ai/code/session_01JWtUsCyy9ESaq4agyTKnFb
</commit_message>
<xml_diff>
--- a/system-design-101/vi/lessons/sd-04-036/slides/sd-04-036.pptx
+++ b/system-design-101/vi/lessons/sd-04-036/slides/sd-04-036.pptx
@@ -2069,7 +2069,7 @@
               <a:t> sau</a:t>
             </a:r>
             <a:r>
-              <a:rPr lang="en-US" sz="2250" dirty="0" spc="-1" kern="0">
+              <a:rPr lang="en-US" sz="2250" dirty="0" spc="15" kern="0">
                 <a:solidFill>
                   <a:srgbClr val="9AA0B5"/>
                 </a:solidFill>
@@ -2077,18 +2077,7 @@
                 <a:ea typeface="Be Vietnam Pro" pitchFamily="34" charset="-122"/>
                 <a:cs typeface="Be Vietnam Pro" pitchFamily="34" charset="-120"/>
               </a:rPr>
-              <a:t> khi</a:t>
-            </a:r>
-            <a:r>
-              <a:rPr lang="en-US" sz="2250" dirty="0" spc="0" kern="0">
-                <a:solidFill>
-                  <a:srgbClr val="9AA0B5"/>
-                </a:solidFill>
-                <a:latin typeface="Be Vietnam Pro" pitchFamily="34" charset="0"/>
-                <a:ea typeface="Be Vietnam Pro" pitchFamily="34" charset="-122"/>
-                <a:cs typeface="Be Vietnam Pro" pitchFamily="34" charset="-120"/>
-              </a:rPr>
-              <a:t> chia.</a:t>
+              <a:t> đó.</a:t>
             </a:r>
             <a:endParaRPr lang="en-US" sz="2250" dirty="0"/>
           </a:p>
@@ -3419,51 +3408,7 @@
                 <a:ea typeface="Be Vietnam Pro" pitchFamily="34" charset="-122"/>
                 <a:cs typeface="Be Vietnam Pro" pitchFamily="34" charset="-120"/>
               </a:rPr>
-              <a:t> trúc: hỏi</a:t>
-            </a:r>
-            <a:r>
-              <a:rPr lang="en-US" sz="2550" dirty="0" spc="-19" kern="0">
-                <a:solidFill>
-                  <a:srgbClr val="F3EEE3"/>
-                </a:solidFill>
-                <a:latin typeface="Be Vietnam Pro" pitchFamily="34" charset="0"/>
-                <a:ea typeface="Be Vietnam Pro" pitchFamily="34" charset="-122"/>
-                <a:cs typeface="Be Vietnam Pro" pitchFamily="34" charset="-120"/>
-              </a:rPr>
-              <a:t> và</a:t>
-            </a:r>
-            <a:r>
-              <a:rPr lang="en-US" sz="2550" dirty="0" spc="0" kern="0">
-                <a:solidFill>
-                  <a:srgbClr val="F3EEE3"/>
-                </a:solidFill>
-                <a:latin typeface="Be Vietnam Pro" pitchFamily="34" charset="0"/>
-                <a:ea typeface="Be Vietnam Pro" pitchFamily="34" charset="-122"/>
-                <a:cs typeface="Be Vietnam Pro" pitchFamily="34" charset="-120"/>
-              </a:rPr>
-              <a:t> ghi</a:t>
-            </a:r>
-            <a:r>
-              <a:rPr lang="en-US" sz="2550" dirty="0" spc="-2" kern="0">
-                <a:solidFill>
-                  <a:srgbClr val="F3EEE3"/>
-                </a:solidFill>
-                <a:latin typeface="Be Vietnam Pro" pitchFamily="34" charset="0"/>
-                <a:ea typeface="Be Vietnam Pro" pitchFamily="34" charset="-122"/>
-                <a:cs typeface="Be Vietnam Pro" pitchFamily="34" charset="-120"/>
-              </a:rPr>
-              <a:t> dữ</a:t>
-            </a:r>
-            <a:r>
-              <a:rPr lang="en-US" sz="2550" dirty="0" spc="2" kern="0">
-                <a:solidFill>
-                  <a:srgbClr val="F3EEE3"/>
-                </a:solidFill>
-                <a:latin typeface="Be Vietnam Pro" pitchFamily="34" charset="0"/>
-                <a:ea typeface="Be Vietnam Pro" pitchFamily="34" charset="-122"/>
-                <a:cs typeface="Be Vietnam Pro" pitchFamily="34" charset="-120"/>
-              </a:rPr>
-              <a:t> liệu.</a:t>
+              <a:t> trúc.</a:t>
             </a:r>
             <a:endParaRPr lang="en-US" sz="2550" dirty="0"/>
           </a:p>
@@ -3519,28 +3464,6 @@
               <a:t> shard</a:t>
             </a:r>
             <a:r>
-              <a:rPr lang="en-US" sz="1950" dirty="0" spc="-12" kern="0">
-                <a:solidFill>
-                  <a:srgbClr val="9AA0B5"/>
-                </a:solidFill>
-                <a:latin typeface="Be Vietnam Pro" pitchFamily="34" charset="0"/>
-                <a:ea typeface="Be Vietnam Pro" pitchFamily="34" charset="-122"/>
-                <a:cs typeface="Be Vietnam Pro" pitchFamily="34" charset="-120"/>
-              </a:rPr>
-              <a:t> trong</a:t>
-            </a:r>
-            <a:r>
-              <a:rPr lang="en-US" sz="1950" dirty="0" spc="-1" kern="0">
-                <a:solidFill>
-                  <a:srgbClr val="9AA0B5"/>
-                </a:solidFill>
-                <a:latin typeface="Be Vietnam Pro" pitchFamily="34" charset="0"/>
-                <a:ea typeface="Be Vietnam Pro" pitchFamily="34" charset="-122"/>
-                <a:cs typeface="Be Vietnam Pro" pitchFamily="34" charset="-120"/>
-              </a:rPr>
-              <a:t> phép thử</a:t>
-            </a:r>
-            <a:r>
               <a:rPr lang="en-US" sz="1950" dirty="0" spc="-2" kern="0">
                 <a:solidFill>
                   <a:srgbClr val="9AA0B5"/>
@@ -3826,7 +3749,7 @@
               <a:t> shard,</a:t>
             </a:r>
             <a:r>
-              <a:rPr lang="en-US" sz="1950" dirty="0" spc="-7" kern="0">
+              <a:rPr lang="en-US" sz="1950" dirty="0" spc="-2" kern="0">
                 <a:solidFill>
                   <a:srgbClr val="9AA0B5"/>
                 </a:solidFill>
@@ -3834,10 +3757,10 @@
                 <a:ea typeface="Be Vietnam Pro" pitchFamily="34" charset="-122"/>
                 <a:cs typeface="Be Vietnam Pro" pitchFamily="34" charset="-120"/>
               </a:rPr>
-              <a:t> thuật</a:t>
-            </a:r>
-            <a:r>
-              <a:rPr lang="en-US" sz="1950" dirty="0" spc="-10" kern="0">
+              <a:t> cách</a:t>
+            </a:r>
+            <a:r>
+              <a:rPr lang="en-US" sz="1950" dirty="0" spc="0" kern="0">
                 <a:solidFill>
                   <a:srgbClr val="9AA0B5"/>
                 </a:solidFill>
@@ -3845,7 +3768,18 @@
                 <a:ea typeface="Be Vietnam Pro" pitchFamily="34" charset="-122"/>
                 <a:cs typeface="Be Vietnam Pro" pitchFamily="34" charset="-120"/>
               </a:rPr>
-              <a:t> toán</a:t>
+              <a:t> chia,</a:t>
+            </a:r>
+            <a:r>
+              <a:rPr lang="en-US" sz="1950" dirty="0" spc="-3" kern="0">
+                <a:solidFill>
+                  <a:srgbClr val="9AA0B5"/>
+                </a:solidFill>
+                <a:latin typeface="Be Vietnam Pro" pitchFamily="34" charset="0"/>
+                <a:ea typeface="Be Vietnam Pro" pitchFamily="34" charset="-122"/>
+                <a:cs typeface="Be Vietnam Pro" pitchFamily="34" charset="-120"/>
+              </a:rPr>
+              <a:t> chỗ</a:t>
             </a:r>
             <a:r>
               <a:rPr lang="en-US" sz="1950" dirty="0" spc="0" kern="0">
@@ -3856,7 +3790,18 @@
                 <a:ea typeface="Be Vietnam Pro" pitchFamily="34" charset="-122"/>
                 <a:cs typeface="Be Vietnam Pro" pitchFamily="34" charset="-120"/>
               </a:rPr>
-              <a:t> chia,</a:t>
+              <a:t> đặt</a:t>
+            </a:r>
+            <a:r>
+              <a:rPr lang="en-US" sz="1950" dirty="0" spc="-1" kern="0">
+                <a:solidFill>
+                  <a:srgbClr val="9AA0B5"/>
+                </a:solidFill>
+                <a:latin typeface="Be Vietnam Pro" pitchFamily="34" charset="0"/>
+                <a:ea typeface="Be Vietnam Pro" pitchFamily="34" charset="-122"/>
+                <a:cs typeface="Be Vietnam Pro" pitchFamily="34" charset="-120"/>
+              </a:rPr>
+              <a:t> logic,</a:t>
             </a:r>
             <a:r>
               <a:rPr lang="en-US" sz="1950" dirty="0" spc="-4" kern="0">
@@ -3867,7 +3812,7 @@
                 <a:ea typeface="Be Vietnam Pro" pitchFamily="34" charset="-122"/>
                 <a:cs typeface="Be Vietnam Pro" pitchFamily="34" charset="-120"/>
               </a:rPr>
-              <a:t> ba</a:t>
+              <a:t> bốn</a:t>
             </a:r>
             <a:r>
               <a:rPr lang="en-US" sz="1950" dirty="0" spc="-2" kern="0">
@@ -3878,29 +3823,7 @@
                 <a:ea typeface="Be Vietnam Pro" pitchFamily="34" charset="-122"/>
                 <a:cs typeface="Be Vietnam Pro" pitchFamily="34" charset="-120"/>
               </a:rPr>
-              <a:t> chỗ</a:t>
-            </a:r>
-            <a:r>
-              <a:rPr lang="en-US" sz="1950" dirty="0" spc="-1" kern="0">
-                <a:solidFill>
-                  <a:srgbClr val="9AA0B5"/>
-                </a:solidFill>
-                <a:latin typeface="Be Vietnam Pro" pitchFamily="34" charset="0"/>
-                <a:ea typeface="Be Vietnam Pro" pitchFamily="34" charset="-122"/>
-                <a:cs typeface="Be Vietnam Pro" pitchFamily="34" charset="-120"/>
-              </a:rPr>
-              <a:t> đặt logic,</a:t>
-            </a:r>
-            <a:r>
-              <a:rPr lang="en-US" sz="1950" dirty="0" spc="-3" kern="0">
-                <a:solidFill>
-                  <a:srgbClr val="9AA0B5"/>
-                </a:solidFill>
-                <a:latin typeface="Be Vietnam Pro" pitchFamily="34" charset="0"/>
-                <a:ea typeface="Be Vietnam Pro" pitchFamily="34" charset="-122"/>
-                <a:cs typeface="Be Vietnam Pro" pitchFamily="34" charset="-120"/>
-              </a:rPr>
-              <a:t> bốn khó</a:t>
+              <a:t> khó</a:t>
             </a:r>
             <a:r>
               <a:rPr lang="en-US" sz="1950" dirty="0" spc="-1" kern="0">
@@ -5345,7 +5268,7 @@
                 <a:ea typeface="Be Vietnam Pro" pitchFamily="34" charset="-122"/>
                 <a:cs typeface="Be Vietnam Pro" pitchFamily="34" charset="-120"/>
               </a:rPr>
-              <a:t> khách: mã</a:t>
+              <a:t> khách:</a:t>
             </a:r>
             <a:r>
               <a:rPr lang="en-US" sz="2700" dirty="0" spc="0" kern="0">
@@ -5356,7 +5279,7 @@
                 <a:ea typeface="Be Vietnam Pro" pitchFamily="34" charset="-122"/>
                 <a:cs typeface="Be Vietnam Pro" pitchFamily="34" charset="-120"/>
               </a:rPr>
-              <a:t> khách</a:t>
+              <a:t> chia</a:t>
             </a:r>
             <a:r>
               <a:rPr lang="en-US" sz="2700" dirty="0" spc="-1" kern="0">
@@ -5367,32 +5290,10 @@
                 <a:ea typeface="Be Vietnam Pro" pitchFamily="34" charset="-122"/>
                 <a:cs typeface="Be Vietnam Pro" pitchFamily="34" charset="-120"/>
               </a:rPr>
-              <a:t> chia</a:t>
-            </a:r>
-            <a:r>
-              <a:rPr lang="en-US" sz="2700" dirty="0" spc="0" kern="0">
-                <a:solidFill>
-                  <a:srgbClr val="14161C"/>
-                </a:solidFill>
-                <a:latin typeface="Be Vietnam Pro" pitchFamily="34" charset="0"/>
-                <a:ea typeface="Be Vietnam Pro" pitchFamily="34" charset="-122"/>
-                <a:cs typeface="Be Vietnam Pro" pitchFamily="34" charset="-120"/>
-              </a:rPr>
-              <a:t> dư</a:t>
-            </a:r>
-            <a:r>
-              <a:rPr lang="en-US" sz="2700" dirty="0" spc="-1" kern="0">
-                <a:solidFill>
-                  <a:srgbClr val="14161C"/>
-                </a:solidFill>
-                <a:latin typeface="Be Vietnam Pro" pitchFamily="34" charset="0"/>
-                <a:ea typeface="Be Vietnam Pro" pitchFamily="34" charset="-122"/>
-                <a:cs typeface="Be Vietnam Pro" pitchFamily="34" charset="-120"/>
-              </a:rPr>
-              <a:t> cho</a:t>
-            </a:r>
-            <a:r>
-              <a:rPr lang="en-US" sz="2700" dirty="0" spc="0" kern="0">
+              <a:t> dư cho</a:t>
+            </a:r>
+            <a:r>
+              <a:rPr lang="en-US" sz="2700" dirty="0" spc="1" kern="0">
                 <a:solidFill>
                   <a:srgbClr val="14161C"/>
                 </a:solidFill>
@@ -5442,6 +5343,61 @@
               <a:t>Khách</a:t>
             </a:r>
             <a:r>
+              <a:rPr lang="en-US" sz="2100" dirty="0" spc="-3" kern="0">
+                <a:solidFill>
+                  <a:srgbClr val="6B6A66"/>
+                </a:solidFill>
+                <a:latin typeface="Be Vietnam Pro" pitchFamily="34" charset="0"/>
+                <a:ea typeface="Be Vietnam Pro" pitchFamily="34" charset="-122"/>
+                <a:cs typeface="Be Vietnam Pro" pitchFamily="34" charset="-120"/>
+              </a:rPr>
+              <a:t> 7</a:t>
+            </a:r>
+            <a:r>
+              <a:rPr lang="en-US" sz="2100" dirty="0" spc="-2" kern="0">
+                <a:solidFill>
+                  <a:srgbClr val="6B6A66"/>
+                </a:solidFill>
+                <a:latin typeface="Be Vietnam Pro" pitchFamily="34" charset="0"/>
+                <a:ea typeface="Be Vietnam Pro" pitchFamily="34" charset="-122"/>
+                <a:cs typeface="Be Vietnam Pro" pitchFamily="34" charset="-120"/>
+              </a:rPr>
+              <a:t> đặt</a:t>
+            </a:r>
+            <a:r>
+              <a:rPr lang="en-US" sz="2100" dirty="0" spc="-8" kern="0">
+                <a:solidFill>
+                  <a:srgbClr val="6B6A66"/>
+                </a:solidFill>
+                <a:latin typeface="Be Vietnam Pro" pitchFamily="34" charset="0"/>
+                <a:ea typeface="Be Vietnam Pro" pitchFamily="34" charset="-122"/>
+                <a:cs typeface="Be Vietnam Pro" pitchFamily="34" charset="-120"/>
+              </a:rPr>
+              <a:t> một</a:t>
+            </a:r>
+            <a:r>
+              <a:rPr lang="en-US" sz="2100" dirty="0" spc="-2" kern="0">
+                <a:solidFill>
+                  <a:srgbClr val="6B6A66"/>
+                </a:solidFill>
+                <a:latin typeface="Be Vietnam Pro" pitchFamily="34" charset="0"/>
+                <a:ea typeface="Be Vietnam Pro" pitchFamily="34" charset="-122"/>
+                <a:cs typeface="Be Vietnam Pro" pitchFamily="34" charset="-120"/>
+              </a:rPr>
+              <a:t> phần</a:t>
+            </a:r>
+            <a:r>
+              <a:rPr lang="en-US" sz="2100" dirty="0" spc="-1" kern="0">
+                <a:solidFill>
+                  <a:srgbClr val="6B6A66"/>
+                </a:solidFill>
+                <a:latin typeface="Be Vietnam Pro" pitchFamily="34" charset="0"/>
+                <a:ea typeface="Be Vietnam Pro" pitchFamily="34" charset="-122"/>
+                <a:cs typeface="Be Vietnam Pro" pitchFamily="34" charset="-120"/>
+              </a:rPr>
+              <a:t> năm</a:t>
+            </a:r>
+            <a:r>
               <a:rPr lang="en-US" sz="2100" dirty="0" spc="-9" kern="0">
                 <a:solidFill>
                   <a:srgbClr val="6B6A66"/>
@@ -5453,7 +5409,7 @@
               <a:t> số</a:t>
             </a:r>
             <a:r>
-              <a:rPr lang="en-US" sz="2100" dirty="0" spc="-3" kern="0">
+              <a:rPr lang="en-US" sz="2100" dirty="0" spc="8" kern="0">
                 <a:solidFill>
                   <a:srgbClr val="6B6A66"/>
                 </a:solidFill>
@@ -5461,84 +5417,7 @@
                 <a:ea typeface="Be Vietnam Pro" pitchFamily="34" charset="-122"/>
                 <a:cs typeface="Be Vietnam Pro" pitchFamily="34" charset="-120"/>
               </a:rPr>
-              <a:t> 7</a:t>
-            </a:r>
-            <a:r>
-              <a:rPr lang="en-US" sz="2100" dirty="0" spc="-2" kern="0">
-                <a:solidFill>
-                  <a:srgbClr val="6B6A66"/>
-                </a:solidFill>
-                <a:latin typeface="Be Vietnam Pro" pitchFamily="34" charset="0"/>
-                <a:ea typeface="Be Vietnam Pro" pitchFamily="34" charset="-122"/>
-                <a:cs typeface="Be Vietnam Pro" pitchFamily="34" charset="-120"/>
-              </a:rPr>
-              <a:t> đặt</a:t>
-            </a:r>
-            <a:r>
-              <a:rPr lang="en-US" sz="2100" dirty="0" spc="-8" kern="0">
-                <a:solidFill>
-                  <a:srgbClr val="6B6A66"/>
-                </a:solidFill>
-                <a:latin typeface="Be Vietnam Pro" pitchFamily="34" charset="0"/>
-                <a:ea typeface="Be Vietnam Pro" pitchFamily="34" charset="-122"/>
-                <a:cs typeface="Be Vietnam Pro" pitchFamily="34" charset="-120"/>
-              </a:rPr>
-              <a:t> một</a:t>
-            </a:r>
-            <a:r>
-              <a:rPr lang="en-US" sz="2100" dirty="0" spc="-2" kern="0">
-                <a:solidFill>
-                  <a:srgbClr val="6B6A66"/>
-                </a:solidFill>
-                <a:latin typeface="Be Vietnam Pro" pitchFamily="34" charset="0"/>
-                <a:ea typeface="Be Vietnam Pro" pitchFamily="34" charset="-122"/>
-                <a:cs typeface="Be Vietnam Pro" pitchFamily="34" charset="-120"/>
-              </a:rPr>
-              <a:t> phần</a:t>
-            </a:r>
-            <a:r>
-              <a:rPr lang="en-US" sz="2100" dirty="0" spc="-1" kern="0">
-                <a:solidFill>
-                  <a:srgbClr val="6B6A66"/>
-                </a:solidFill>
-                <a:latin typeface="Be Vietnam Pro" pitchFamily="34" charset="0"/>
-                <a:ea typeface="Be Vietnam Pro" pitchFamily="34" charset="-122"/>
-                <a:cs typeface="Be Vietnam Pro" pitchFamily="34" charset="-120"/>
-              </a:rPr>
-              <a:t> năm</a:t>
-            </a:r>
-            <a:r>
-              <a:rPr lang="en-US" sz="2100" dirty="0" spc="-9" kern="0">
-                <a:solidFill>
-                  <a:srgbClr val="6B6A66"/>
-                </a:solidFill>
-                <a:latin typeface="Be Vietnam Pro" pitchFamily="34" charset="0"/>
-                <a:ea typeface="Be Vietnam Pro" pitchFamily="34" charset="-122"/>
-                <a:cs typeface="Be Vietnam Pro" pitchFamily="34" charset="-120"/>
-              </a:rPr>
-              <a:t> số</a:t>
-            </a:r>
-            <a:r>
-              <a:rPr lang="en-US" sz="2100" dirty="0" spc="8" kern="0">
-                <a:solidFill>
-                  <a:srgbClr val="6B6A66"/>
-                </a:solidFill>
-                <a:latin typeface="Be Vietnam Pro" pitchFamily="34" charset="0"/>
-                <a:ea typeface="Be Vietnam Pro" pitchFamily="34" charset="-122"/>
-                <a:cs typeface="Be Vietnam Pro" pitchFamily="34" charset="-120"/>
-              </a:rPr>
               <a:t> đơn,</a:t>
-            </a:r>
-            <a:r>
-              <a:rPr lang="en-US" sz="2100" dirty="0" spc="-12" kern="0">
-                <a:solidFill>
-                  <a:srgbClr val="6B6A66"/>
-                </a:solidFill>
-                <a:latin typeface="Be Vietnam Pro" pitchFamily="34" charset="0"/>
-                <a:ea typeface="Be Vietnam Pro" pitchFamily="34" charset="-122"/>
-                <a:cs typeface="Be Vietnam Pro" pitchFamily="34" charset="-120"/>
-              </a:rPr>
-              <a:t> toàn</a:t>
             </a:r>
             <a:r>
               <a:rPr lang="en-US" sz="2100" dirty="0" spc="-2" kern="0">
@@ -8684,6 +8563,39 @@
               <a:t>Khách</a:t>
             </a:r>
             <a:r>
+              <a:rPr lang="en-US" sz="2250" dirty="0" spc="2" kern="0">
+                <a:solidFill>
+                  <a:srgbClr val="9AA0B5"/>
+                </a:solidFill>
+                <a:latin typeface="Be Vietnam Pro" pitchFamily="34" charset="0"/>
+                <a:ea typeface="Be Vietnam Pro" pitchFamily="34" charset="-122"/>
+                <a:cs typeface="Be Vietnam Pro" pitchFamily="34" charset="-120"/>
+              </a:rPr>
+              <a:t> 7</a:t>
+            </a:r>
+            <a:r>
+              <a:rPr lang="en-US" sz="2250" dirty="0" spc="0" kern="0">
+                <a:solidFill>
+                  <a:srgbClr val="9AA0B5"/>
+                </a:solidFill>
+                <a:latin typeface="Be Vietnam Pro" pitchFamily="34" charset="0"/>
+                <a:ea typeface="Be Vietnam Pro" pitchFamily="34" charset="-122"/>
+                <a:cs typeface="Be Vietnam Pro" pitchFamily="34" charset="-120"/>
+              </a:rPr>
+              <a:t> đặt 2.000</a:t>
+            </a:r>
+            <a:r>
+              <a:rPr lang="en-US" sz="2250" dirty="0" spc="9" kern="0">
+                <a:solidFill>
+                  <a:srgbClr val="9AA0B5"/>
+                </a:solidFill>
+                <a:latin typeface="Be Vietnam Pro" pitchFamily="34" charset="0"/>
+                <a:ea typeface="Be Vietnam Pro" pitchFamily="34" charset="-122"/>
+                <a:cs typeface="Be Vietnam Pro" pitchFamily="34" charset="-120"/>
+              </a:rPr>
+              <a:t> đơn;</a:t>
+            </a:r>
+            <a:r>
               <a:rPr lang="en-US" sz="2250" dirty="0" spc="-3" kern="0">
                 <a:solidFill>
                   <a:srgbClr val="9AA0B5"/>
@@ -8692,10 +8604,10 @@
                 <a:ea typeface="Be Vietnam Pro" pitchFamily="34" charset="-122"/>
                 <a:cs typeface="Be Vietnam Pro" pitchFamily="34" charset="-120"/>
               </a:rPr>
-              <a:t> số</a:t>
-            </a:r>
-            <a:r>
-              <a:rPr lang="en-US" sz="2250" dirty="0" spc="3" kern="0">
+              <a:t> băm</a:t>
+            </a:r>
+            <a:r>
+              <a:rPr lang="en-US" sz="2250" dirty="0" spc="12" kern="0">
                 <a:solidFill>
                   <a:srgbClr val="9AA0B5"/>
                 </a:solidFill>
@@ -8703,10 +8615,10 @@
                 <a:ea typeface="Be Vietnam Pro" pitchFamily="34" charset="-122"/>
                 <a:cs typeface="Be Vietnam Pro" pitchFamily="34" charset="-120"/>
               </a:rPr>
-              <a:t> 7</a:t>
-            </a:r>
-            <a:r>
-              <a:rPr lang="en-US" sz="2250" dirty="0" spc="0" kern="0">
+              <a:t> đều</a:t>
+            </a:r>
+            <a:r>
+              <a:rPr lang="en-US" sz="2250" dirty="0" spc="1" kern="0">
                 <a:solidFill>
                   <a:srgbClr val="9AA0B5"/>
                 </a:solidFill>
@@ -8714,10 +8626,10 @@
                 <a:ea typeface="Be Vietnam Pro" pitchFamily="34" charset="-122"/>
                 <a:cs typeface="Be Vietnam Pro" pitchFamily="34" charset="-120"/>
               </a:rPr>
-              <a:t> đặt 2.000</a:t>
-            </a:r>
-            <a:r>
-              <a:rPr lang="en-US" sz="2250" dirty="0" spc="11" kern="0">
+              <a:t> không</a:t>
+            </a:r>
+            <a:r>
+              <a:rPr lang="en-US" sz="2250" dirty="0" spc="20" kern="0">
                 <a:solidFill>
                   <a:srgbClr val="9AA0B5"/>
                 </a:solidFill>
@@ -8725,76 +8637,10 @@
                 <a:ea typeface="Be Vietnam Pro" pitchFamily="34" charset="-122"/>
                 <a:cs typeface="Be Vietnam Pro" pitchFamily="34" charset="-120"/>
               </a:rPr>
-              <a:t> đơn.</a:t>
-            </a:r>
-            <a:r>
-              <a:rPr lang="en-US" sz="2250" dirty="0" spc="0" kern="0">
-                <a:solidFill>
-                  <a:srgbClr val="9AA0B5"/>
-                </a:solidFill>
-                <a:latin typeface="Be Vietnam Pro" pitchFamily="34" charset="0"/>
-                <a:ea typeface="Be Vietnam Pro" pitchFamily="34" charset="-122"/>
-                <a:cs typeface="Be Vietnam Pro" pitchFamily="34" charset="-120"/>
-              </a:rPr>
-              <a:t> Băm</a:t>
-            </a:r>
-            <a:r>
-              <a:rPr lang="en-US" sz="2250" dirty="0" spc="12" kern="0">
-                <a:solidFill>
-                  <a:srgbClr val="9AA0B5"/>
-                </a:solidFill>
-                <a:latin typeface="Be Vietnam Pro" pitchFamily="34" charset="0"/>
-                <a:ea typeface="Be Vietnam Pro" pitchFamily="34" charset="-122"/>
-                <a:cs typeface="Be Vietnam Pro" pitchFamily="34" charset="-120"/>
-              </a:rPr>
-              <a:t> đều</a:t>
-            </a:r>
-            <a:r>
-              <a:rPr lang="en-US" sz="2250" dirty="0" spc="-2" kern="0">
-                <a:solidFill>
-                  <a:srgbClr val="9AA0B5"/>
-                </a:solidFill>
-                <a:latin typeface="Be Vietnam Pro" pitchFamily="34" charset="0"/>
-                <a:ea typeface="Be Vietnam Pro" pitchFamily="34" charset="-122"/>
-                <a:cs typeface="Be Vietnam Pro" pitchFamily="34" charset="-120"/>
-              </a:rPr>
-              <a:t> mã</a:t>
-            </a:r>
-            <a:r>
-              <a:rPr lang="en-US" sz="2250" dirty="0" spc="0" kern="0">
-                <a:solidFill>
-                  <a:srgbClr val="9AA0B5"/>
-                </a:solidFill>
-                <a:latin typeface="Be Vietnam Pro" pitchFamily="34" charset="0"/>
-                <a:ea typeface="Be Vietnam Pro" pitchFamily="34" charset="-122"/>
-                <a:cs typeface="Be Vietnam Pro" pitchFamily="34" charset="-120"/>
-              </a:rPr>
-              <a:t> khách</a:t>
-            </a:r>
-            <a:r>
-              <a:rPr lang="en-US" sz="2250" dirty="0" spc="1" kern="0">
-                <a:solidFill>
-                  <a:srgbClr val="9AA0B5"/>
-                </a:solidFill>
-                <a:latin typeface="Be Vietnam Pro" pitchFamily="34" charset="0"/>
-                <a:ea typeface="Be Vietnam Pro" pitchFamily="34" charset="-122"/>
-                <a:cs typeface="Be Vietnam Pro" pitchFamily="34" charset="-120"/>
-              </a:rPr>
-              <a:t> không</a:t>
-            </a:r>
-            <a:r>
-              <a:rPr lang="en-US" sz="2250" dirty="0" spc="20" kern="0">
-                <a:solidFill>
-                  <a:srgbClr val="9AA0B5"/>
-                </a:solidFill>
-                <a:latin typeface="Be Vietnam Pro" pitchFamily="34" charset="0"/>
-                <a:ea typeface="Be Vietnam Pro" pitchFamily="34" charset="-122"/>
-                <a:cs typeface="Be Vietnam Pro" pitchFamily="34" charset="-120"/>
-              </a:rPr>
               <a:t> cứu</a:t>
             </a:r>
             <a:r>
-              <a:rPr lang="en-US" sz="2250" dirty="0" spc="9" kern="0">
+              <a:rPr lang="en-US" sz="2250" dirty="0" spc="8" kern="0">
                 <a:solidFill>
                   <a:srgbClr val="9AA0B5"/>
                 </a:solidFill>
@@ -10181,10 +10027,10 @@
                 <a:ea typeface="Be Vietnam Pro" pitchFamily="34" charset="-122"/>
                 <a:cs typeface="Be Vietnam Pro" pitchFamily="34" charset="-120"/>
               </a:rPr>
-              <a:t> tính trung bình</a:t>
-            </a:r>
-            <a:r>
-              <a:rPr lang="en-US" sz="2550" dirty="0" spc="7" kern="0">
+              <a:t> tính trung</a:t>
+            </a:r>
+            <a:r>
+              <a:rPr lang="en-US" sz="2550" dirty="0" spc="0" kern="0">
                 <a:solidFill>
                   <a:srgbClr val="14161C"/>
                 </a:solidFill>
@@ -10192,10 +10038,10 @@
                 <a:ea typeface="Be Vietnam Pro" pitchFamily="34" charset="-122"/>
                 <a:cs typeface="Be Vietnam Pro" pitchFamily="34" charset="-120"/>
               </a:rPr>
-              <a:t> riêng,</a:t>
-            </a:r>
-            <a:r>
-              <a:rPr lang="en-US" sz="2550" dirty="0" spc="-27" kern="0">
+              <a:t> bình,</a:t>
+            </a:r>
+            <a:r>
+              <a:rPr lang="en-US" sz="2550" dirty="0" spc="-26" kern="0">
                 <a:solidFill>
                   <a:srgbClr val="14161C"/>
                 </a:solidFill>
@@ -10217,7 +10063,7 @@
               <a:t> lấy</a:t>
             </a:r>
             <a:r>
-              <a:rPr lang="en-US" sz="2550" dirty="0" spc="2" kern="0">
+              <a:rPr lang="en-US" sz="2550" dirty="0" spc="1" kern="0">
                 <a:solidFill>
                   <a:srgbClr val="14161C"/>
                 </a:solidFill>
@@ -10225,7 +10071,7 @@
                 <a:ea typeface="Be Vietnam Pro" pitchFamily="34" charset="-122"/>
                 <a:cs typeface="Be Vietnam Pro" pitchFamily="34" charset="-120"/>
               </a:rPr>
-              <a:t> trung</a:t>
+              <a:t> trung bình</a:t>
             </a:r>
             <a:r>
               <a:rPr lang="en-US" sz="2550" dirty="0" spc="0" kern="0">
@@ -10236,7 +10082,7 @@
                 <a:ea typeface="Be Vietnam Pro" pitchFamily="34" charset="-122"/>
                 <a:cs typeface="Be Vietnam Pro" pitchFamily="34" charset="-120"/>
               </a:rPr>
-              <a:t> bình tiếp</a:t>
+              <a:t> tiếp</a:t>
             </a:r>
             <a:endParaRPr lang="en-US" sz="2550" dirty="0"/>
           </a:p>
@@ -12359,17 +12205,17 @@
           <a:ln/>
         </p:spPr>
         <p:txBody>
-          <a:bodyPr wrap="square" lIns="0" tIns="15407" rIns="0" bIns="-15407" rtlCol="0" anchor="t"/>
+          <a:bodyPr wrap="square" lIns="0" tIns="16192" rIns="0" bIns="-16192" rtlCol="0" anchor="t"/>
           <a:lstStyle/>
           <a:p>
             <a:pPr algn="l" indent="0" marL="0">
               <a:lnSpc>
-                <a:spcPts val="3716"/>
+                <a:spcPts val="3900"/>
               </a:lnSpc>
               <a:buNone/>
             </a:pPr>
             <a:r>
-              <a:rPr lang="en-US" sz="2858" b="1" dirty="0" spc="1" kern="0">
+              <a:rPr lang="en-US" sz="3000" b="1" dirty="0" spc="2" kern="0">
                 <a:solidFill>
                   <a:srgbClr val="14161C"/>
                 </a:solidFill>
@@ -12380,7 +12226,7 @@
               <a:t>Cần</a:t>
             </a:r>
             <a:r>
-              <a:rPr lang="en-US" sz="2858" b="1" dirty="0" spc="3" kern="0">
+              <a:rPr lang="en-US" sz="3000" b="1" dirty="0" spc="4" kern="0">
                 <a:solidFill>
                   <a:srgbClr val="14161C"/>
                 </a:solidFill>
@@ -12391,7 +12237,7 @@
               <a:t> giao</a:t>
             </a:r>
             <a:r>
-              <a:rPr lang="en-US" sz="2858" b="1" dirty="0" spc="-2" kern="0">
+              <a:rPr lang="en-US" sz="3000" b="1" dirty="0" spc="3" kern="0">
                 <a:solidFill>
                   <a:srgbClr val="14161C"/>
                 </a:solidFill>
@@ -12402,7 +12248,7 @@
               <a:t> dịch</a:t>
             </a:r>
             <a:r>
-              <a:rPr lang="en-US" sz="2858" b="1" dirty="0" spc="-8" kern="0">
+              <a:rPr lang="en-US" sz="3000" b="1" dirty="0" spc="-6" kern="0">
                 <a:solidFill>
                   <a:srgbClr val="14161C"/>
                 </a:solidFill>
@@ -12413,7 +12259,7 @@
               <a:t> phân</a:t>
             </a:r>
             <a:r>
-              <a:rPr lang="en-US" sz="2858" b="1" dirty="0" spc="-5" kern="0">
+              <a:rPr lang="en-US" sz="3000" b="1" dirty="0" spc="-3" kern="0">
                 <a:solidFill>
                   <a:srgbClr val="14161C"/>
                 </a:solidFill>
@@ -12424,7 +12270,7 @@
               <a:t> tán,</a:t>
             </a:r>
             <a:r>
-              <a:rPr lang="en-US" sz="2858" b="1" dirty="0" spc="-8" kern="0">
+              <a:rPr lang="en-US" sz="3000" b="1" dirty="0" spc="0" kern="0">
                 <a:solidFill>
                   <a:srgbClr val="14161C"/>
                 </a:solidFill>
@@ -12432,10 +12278,10 @@
                 <a:ea typeface="Be Vietnam Pro" pitchFamily="34" charset="-122"/>
                 <a:cs typeface="Be Vietnam Pro" pitchFamily="34" charset="-120"/>
               </a:rPr>
-              <a:t> chẳng</a:t>
-            </a:r>
-            <a:r>
-              <a:rPr lang="en-US" sz="2858" b="1" dirty="0" spc="-5" kern="0">
+              <a:t> như</a:t>
+            </a:r>
+            <a:r>
+              <a:rPr lang="en-US" sz="3000" b="1" dirty="0" spc="-2" kern="0">
                 <a:solidFill>
                   <a:srgbClr val="14161C"/>
                 </a:solidFill>
@@ -12443,10 +12289,10 @@
                 <a:ea typeface="Be Vietnam Pro" pitchFamily="34" charset="-122"/>
                 <a:cs typeface="Be Vietnam Pro" pitchFamily="34" charset="-120"/>
               </a:rPr>
-              <a:t> hạn</a:t>
-            </a:r>
-            <a:r>
-              <a:rPr lang="en-US" sz="2858" b="1" dirty="0" spc="-3" kern="0">
+              <a:t> cam</a:t>
+            </a:r>
+            <a:r>
+              <a:rPr lang="en-US" sz="3000" b="1" dirty="0" spc="-36" kern="0">
                 <a:solidFill>
                   <a:srgbClr val="14161C"/>
                 </a:solidFill>
@@ -12454,10 +12300,10 @@
                 <a:ea typeface="Be Vietnam Pro" pitchFamily="34" charset="-122"/>
                 <a:cs typeface="Be Vietnam Pro" pitchFamily="34" charset="-120"/>
               </a:rPr>
-              <a:t> cam</a:t>
-            </a:r>
-            <a:r>
-              <a:rPr lang="en-US" sz="2858" b="1" dirty="0" spc="-35" kern="0">
+              <a:t> kết</a:t>
+            </a:r>
+            <a:r>
+              <a:rPr lang="en-US" sz="3000" b="1" dirty="0" spc="-2" kern="0">
                 <a:solidFill>
                   <a:srgbClr val="14161C"/>
                 </a:solidFill>
@@ -12465,10 +12311,10 @@
                 <a:ea typeface="Be Vietnam Pro" pitchFamily="34" charset="-122"/>
                 <a:cs typeface="Be Vietnam Pro" pitchFamily="34" charset="-120"/>
               </a:rPr>
-              <a:t> kết</a:t>
-            </a:r>
-            <a:r>
-              <a:rPr lang="en-US" sz="2858" b="1" dirty="0" spc="-3" kern="0">
+              <a:t> hai</a:t>
+            </a:r>
+            <a:r>
+              <a:rPr lang="en-US" sz="3000" b="1" dirty="0" spc="-8" kern="0">
                 <a:solidFill>
                   <a:srgbClr val="14161C"/>
                 </a:solidFill>
@@ -12476,20 +12322,9 @@
                 <a:ea typeface="Be Vietnam Pro" pitchFamily="34" charset="-122"/>
                 <a:cs typeface="Be Vietnam Pro" pitchFamily="34" charset="-120"/>
               </a:rPr>
-              <a:t> hai</a:t>
-            </a:r>
-            <a:r>
-              <a:rPr lang="en-US" sz="2858" b="1" dirty="0" spc="-10" kern="0">
-                <a:solidFill>
-                  <a:srgbClr val="14161C"/>
-                </a:solidFill>
-                <a:latin typeface="Be Vietnam Pro" pitchFamily="34" charset="0"/>
-                <a:ea typeface="Be Vietnam Pro" pitchFamily="34" charset="-122"/>
-                <a:cs typeface="Be Vietnam Pro" pitchFamily="34" charset="-120"/>
-              </a:rPr>
               <a:t> pha</a:t>
             </a:r>
-            <a:endParaRPr lang="en-US" sz="2858" dirty="0"/>
+            <a:endParaRPr lang="en-US" sz="3000" dirty="0"/>
           </a:p>
         </p:txBody>
       </p:sp>
@@ -12681,7 +12516,7 @@
               <a:t> lý</a:t>
             </a:r>
             <a:r>
-              <a:rPr lang="en-US" sz="1950" dirty="0" spc="2" kern="0">
+              <a:rPr lang="en-US" sz="1950" dirty="0" spc="-5" kern="0">
                 <a:solidFill>
                   <a:srgbClr val="6B6A66"/>
                 </a:solidFill>
@@ -12689,10 +12524,10 @@
                 <a:ea typeface="Be Vietnam Pro" pitchFamily="34" charset="-122"/>
                 <a:cs typeface="Be Vietnam Pro" pitchFamily="34" charset="-120"/>
               </a:rPr>
-              <a:t> giao</a:t>
-            </a:r>
-            <a:r>
-              <a:rPr lang="en-US" sz="1950" dirty="0" spc="-2" kern="0">
+              <a:t> ngoài;</a:t>
+            </a:r>
+            <a:r>
+              <a:rPr lang="en-US" sz="1950" dirty="0" spc="22" kern="0">
                 <a:solidFill>
                   <a:srgbClr val="6B6A66"/>
                 </a:solidFill>
@@ -12700,10 +12535,10 @@
                 <a:ea typeface="Be Vietnam Pro" pitchFamily="34" charset="-122"/>
                 <a:cs typeface="Be Vietnam Pro" pitchFamily="34" charset="-120"/>
               </a:rPr>
-              <a:t> dịch</a:t>
-            </a:r>
-            <a:r>
-              <a:rPr lang="en-US" sz="1950" dirty="0" spc="-3" kern="0">
+              <a:t> ứng</a:t>
+            </a:r>
+            <a:r>
+              <a:rPr lang="en-US" sz="1950" dirty="0" spc="1" kern="0">
                 <a:solidFill>
                   <a:srgbClr val="6B6A66"/>
                 </a:solidFill>
@@ -12711,10 +12546,10 @@
                 <a:ea typeface="Be Vietnam Pro" pitchFamily="34" charset="-122"/>
                 <a:cs typeface="Be Vietnam Pro" pitchFamily="34" charset="-120"/>
               </a:rPr>
-              <a:t> bên</a:t>
-            </a:r>
-            <a:r>
-              <a:rPr lang="en-US" sz="1950" dirty="0" spc="-5" kern="0">
+              <a:t> dụng</a:t>
+            </a:r>
+            <a:r>
+              <a:rPr lang="en-US" sz="1950" dirty="0" spc="-1" kern="0">
                 <a:solidFill>
                   <a:srgbClr val="6B6A66"/>
                 </a:solidFill>
@@ -12722,54 +12557,10 @@
                 <a:ea typeface="Be Vietnam Pro" pitchFamily="34" charset="-122"/>
                 <a:cs typeface="Be Vietnam Pro" pitchFamily="34" charset="-120"/>
               </a:rPr>
-              <a:t> ngoài,</a:t>
-            </a:r>
-            <a:r>
-              <a:rPr lang="en-US" sz="1950" dirty="0" spc="-1" kern="0">
-                <a:solidFill>
-                  <a:srgbClr val="6B6A66"/>
-                </a:solidFill>
-                <a:latin typeface="Be Vietnam Pro" pitchFamily="34" charset="0"/>
-                <a:ea typeface="Be Vietnam Pro" pitchFamily="34" charset="-122"/>
-                <a:cs typeface="Be Vietnam Pro" pitchFamily="34" charset="-120"/>
-              </a:rPr>
               <a:t> không</a:t>
             </a:r>
             <a:r>
-              <a:rPr lang="en-US" sz="1950" dirty="0" spc="0" kern="0">
-                <a:solidFill>
-                  <a:srgbClr val="6B6A66"/>
-                </a:solidFill>
-                <a:latin typeface="Be Vietnam Pro" pitchFamily="34" charset="0"/>
-                <a:ea typeface="Be Vietnam Pro" pitchFamily="34" charset="-122"/>
-                <a:cs typeface="Be Vietnam Pro" pitchFamily="34" charset="-120"/>
-              </a:rPr>
-              <a:t> cho</a:t>
-            </a:r>
-            <a:r>
-              <a:rPr lang="en-US" sz="1950" dirty="0" spc="21" kern="0">
-                <a:solidFill>
-                  <a:srgbClr val="6B6A66"/>
-                </a:solidFill>
-                <a:latin typeface="Be Vietnam Pro" pitchFamily="34" charset="0"/>
-                <a:ea typeface="Be Vietnam Pro" pitchFamily="34" charset="-122"/>
-                <a:cs typeface="Be Vietnam Pro" pitchFamily="34" charset="-120"/>
-              </a:rPr>
-              <a:t> ứng</a:t>
-            </a:r>
-            <a:r>
-              <a:rPr lang="en-US" sz="1950" dirty="0" spc="2" kern="0">
-                <a:solidFill>
-                  <a:srgbClr val="6B6A66"/>
-                </a:solidFill>
-                <a:latin typeface="Be Vietnam Pro" pitchFamily="34" charset="0"/>
-                <a:ea typeface="Be Vietnam Pro" pitchFamily="34" charset="-122"/>
-                <a:cs typeface="Be Vietnam Pro" pitchFamily="34" charset="-120"/>
-              </a:rPr>
-              <a:t> dụng</a:t>
-            </a:r>
-            <a:r>
-              <a:rPr lang="en-US" sz="1950" dirty="0" spc="-10" kern="0">
+              <a:rPr lang="en-US" sz="1950" dirty="0" spc="-9" kern="0">
                 <a:solidFill>
                   <a:srgbClr val="6B6A66"/>
                 </a:solidFill>
@@ -14331,7 +14122,7 @@
               <a:buNone/>
             </a:pPr>
             <a:r>
-              <a:rPr lang="en-US" sz="2850" b="1" dirty="0" spc="-16" kern="0">
+              <a:rPr lang="en-US" sz="2850" b="1" dirty="0" spc="0" kern="0">
                 <a:solidFill>
                   <a:srgbClr val="F3EEE3"/>
                 </a:solidFill>
@@ -14339,10 +14130,10 @@
                 <a:ea typeface="Be Vietnam Pro" pitchFamily="34" charset="-122"/>
                 <a:cs typeface="Be Vietnam Pro" pitchFamily="34" charset="-120"/>
               </a:rPr>
-              <a:t>Trước</a:t>
-            </a:r>
-            <a:r>
-              <a:rPr lang="en-US" sz="2850" b="1" dirty="0" spc="0" kern="0">
+              <a:t>Thử</a:t>
+            </a:r>
+            <a:r>
+              <a:rPr lang="en-US" sz="2850" b="1" dirty="0" spc="10" kern="0">
                 <a:solidFill>
                   <a:srgbClr val="F3EEE3"/>
                 </a:solidFill>
@@ -14350,7 +14141,7 @@
                 <a:ea typeface="Be Vietnam Pro" pitchFamily="34" charset="-122"/>
                 <a:cs typeface="Be Vietnam Pro" pitchFamily="34" charset="-120"/>
               </a:rPr>
-              <a:t> khi</a:t>
+              <a:t> trước:</a:t>
             </a:r>
             <a:r>
               <a:rPr lang="en-US" sz="2850" b="1" dirty="0" spc="3" kern="0">
@@ -14361,10 +14152,10 @@
                 <a:ea typeface="Be Vietnam Pro" pitchFamily="34" charset="-122"/>
                 <a:cs typeface="Be Vietnam Pro" pitchFamily="34" charset="-120"/>
               </a:rPr>
-              <a:t> chia:</a:t>
-            </a:r>
-            <a:r>
-              <a:rPr lang="en-US" sz="2850" b="1" dirty="0" spc="10" kern="0">
+              <a:t> bản</a:t>
+            </a:r>
+            <a:r>
+              <a:rPr lang="en-US" sz="2850" b="1" dirty="0" spc="4" kern="0">
                 <a:solidFill>
                   <a:srgbClr val="F3EEE3"/>
                 </a:solidFill>
@@ -14372,10 +14163,10 @@
                 <a:ea typeface="Be Vietnam Pro" pitchFamily="34" charset="-122"/>
                 <a:cs typeface="Be Vietnam Pro" pitchFamily="34" charset="-120"/>
               </a:rPr>
-              <a:t> đã</a:t>
-            </a:r>
-            <a:r>
-              <a:rPr lang="en-US" sz="2850" b="1" dirty="0" spc="0" kern="0">
+              <a:t> sao</a:t>
+            </a:r>
+            <a:r>
+              <a:rPr lang="en-US" sz="2850" b="1" dirty="0" spc="1" kern="0">
                 <a:solidFill>
                   <a:srgbClr val="F3EEE3"/>
                 </a:solidFill>
@@ -14383,7 +14174,29 @@
                 <a:ea typeface="Be Vietnam Pro" pitchFamily="34" charset="-122"/>
                 <a:cs typeface="Be Vietnam Pro" pitchFamily="34" charset="-120"/>
               </a:rPr>
-              <a:t> thử</a:t>
+              <a:t> chỉ</a:t>
+            </a:r>
+            <a:r>
+              <a:rPr lang="en-US" sz="2850" b="1" dirty="0" spc="4" kern="0">
+                <a:solidFill>
+                  <a:srgbClr val="F3EEE3"/>
+                </a:solidFill>
+                <a:latin typeface="Be Vietnam Pro" pitchFamily="34" charset="0"/>
+                <a:ea typeface="Be Vietnam Pro" pitchFamily="34" charset="-122"/>
+                <a:cs typeface="Be Vietnam Pro" pitchFamily="34" charset="-120"/>
+              </a:rPr>
+              <a:t> đọc,</a:t>
+            </a:r>
+            <a:r>
+              <a:rPr lang="en-US" sz="2850" b="1" dirty="0" spc="1" kern="0">
+                <a:solidFill>
+                  <a:srgbClr val="F3EEE3"/>
+                </a:solidFill>
+                <a:latin typeface="Be Vietnam Pro" pitchFamily="34" charset="0"/>
+                <a:ea typeface="Be Vietnam Pro" pitchFamily="34" charset="-122"/>
+                <a:cs typeface="Be Vietnam Pro" pitchFamily="34" charset="-120"/>
+              </a:rPr>
+              <a:t> chỉ</a:t>
             </a:r>
             <a:r>
               <a:rPr lang="en-US" sz="2850" b="1" dirty="0" spc="2" kern="0">
@@ -14394,10 +14207,10 @@
                 <a:ea typeface="Be Vietnam Pro" pitchFamily="34" charset="-122"/>
                 <a:cs typeface="Be Vietnam Pro" pitchFamily="34" charset="-120"/>
               </a:rPr>
-              <a:t> bản</a:t>
-            </a:r>
-            <a:r>
-              <a:rPr lang="en-US" sz="2850" b="1" dirty="0" spc="5" kern="0">
+              <a:t> mục,</a:t>
+            </a:r>
+            <a:r>
+              <a:rPr lang="en-US" sz="2850" b="1" dirty="0" spc="-1" kern="0">
                 <a:solidFill>
                   <a:srgbClr val="F3EEE3"/>
                 </a:solidFill>
@@ -14405,10 +14218,10 @@
                 <a:ea typeface="Be Vietnam Pro" pitchFamily="34" charset="-122"/>
                 <a:cs typeface="Be Vietnam Pro" pitchFamily="34" charset="-120"/>
               </a:rPr>
-              <a:t> sao</a:t>
-            </a:r>
-            <a:r>
-              <a:rPr lang="en-US" sz="2850" b="1" dirty="0" spc="1" kern="0">
+              <a:t> bộ</a:t>
+            </a:r>
+            <a:r>
+              <a:rPr lang="en-US" sz="2850" b="1" dirty="0" spc="3" kern="0">
                 <a:solidFill>
                   <a:srgbClr val="F3EEE3"/>
                 </a:solidFill>
@@ -14416,62 +14229,7 @@
                 <a:ea typeface="Be Vietnam Pro" pitchFamily="34" charset="-122"/>
                 <a:cs typeface="Be Vietnam Pro" pitchFamily="34" charset="-120"/>
               </a:rPr>
-              <a:t> chỉ</a:t>
-            </a:r>
-            <a:r>
-              <a:rPr lang="en-US" sz="2850" b="1" dirty="0" spc="3" kern="0">
-                <a:solidFill>
-                  <a:srgbClr val="F3EEE3"/>
-                </a:solidFill>
-                <a:latin typeface="Be Vietnam Pro" pitchFamily="34" charset="0"/>
-                <a:ea typeface="Be Vietnam Pro" pitchFamily="34" charset="-122"/>
-                <a:cs typeface="Be Vietnam Pro" pitchFamily="34" charset="-120"/>
-              </a:rPr>
-              <a:t> đọc,</a:t>
-            </a:r>
-            <a:r>
-              <a:rPr lang="en-US" sz="2850" b="1" dirty="0" spc="1" kern="0">
-                <a:solidFill>
-                  <a:srgbClr val="F3EEE3"/>
-                </a:solidFill>
-                <a:latin typeface="Be Vietnam Pro" pitchFamily="34" charset="0"/>
-                <a:ea typeface="Be Vietnam Pro" pitchFamily="34" charset="-122"/>
-                <a:cs typeface="Be Vietnam Pro" pitchFamily="34" charset="-120"/>
-              </a:rPr>
-              <a:t> chỉ</a:t>
-            </a:r>
-            <a:r>
-              <a:rPr lang="en-US" sz="2850" b="1" dirty="0" spc="3" kern="0">
-                <a:solidFill>
-                  <a:srgbClr val="F3EEE3"/>
-                </a:solidFill>
-                <a:latin typeface="Be Vietnam Pro" pitchFamily="34" charset="0"/>
-                <a:ea typeface="Be Vietnam Pro" pitchFamily="34" charset="-122"/>
-                <a:cs typeface="Be Vietnam Pro" pitchFamily="34" charset="-120"/>
-              </a:rPr>
-              <a:t> mục,</a:t>
-            </a:r>
-            <a:r>
-              <a:rPr lang="en-US" sz="2850" b="1" dirty="0" spc="-2" kern="0">
-                <a:solidFill>
-                  <a:srgbClr val="F3EEE3"/>
-                </a:solidFill>
-                <a:latin typeface="Be Vietnam Pro" pitchFamily="34" charset="0"/>
-                <a:ea typeface="Be Vietnam Pro" pitchFamily="34" charset="-122"/>
-                <a:cs typeface="Be Vietnam Pro" pitchFamily="34" charset="-120"/>
-              </a:rPr>
-              <a:t> bộ</a:t>
-            </a:r>
-            <a:r>
-              <a:rPr lang="en-US" sz="2850" b="1" dirty="0" spc="2" kern="0">
-                <a:solidFill>
-                  <a:srgbClr val="F3EEE3"/>
-                </a:solidFill>
-                <a:latin typeface="Be Vietnam Pro" pitchFamily="34" charset="0"/>
-                <a:ea typeface="Be Vietnam Pro" pitchFamily="34" charset="-122"/>
-                <a:cs typeface="Be Vietnam Pro" pitchFamily="34" charset="-120"/>
-              </a:rPr>
-              <a:t> đệm?</a:t>
+              <a:t> đệm</a:t>
             </a:r>
             <a:endParaRPr lang="en-US" sz="2850" dirty="0"/>
           </a:p>
@@ -15168,7 +14926,7 @@
                 <a:ea typeface="Bricolage Grotesque ExtraBold" pitchFamily="34" charset="-122"/>
                 <a:cs typeface="Bricolage Grotesque ExtraBold" pitchFamily="34" charset="-120"/>
               </a:rPr>
-              <a:t> tin nhắn theo</a:t>
+              <a:t> theo</a:t>
             </a:r>
             <a:r>
               <a:rPr lang="en-US" sz="5100" dirty="0" spc="-48" kern="0">
@@ -15182,7 +14940,7 @@
               <a:t> người</a:t>
             </a:r>
             <a:r>
-              <a:rPr lang="en-US" sz="5100" dirty="0" spc="20" kern="0">
+              <a:rPr lang="en-US" sz="5100" dirty="0" spc="21" kern="0">
                 <a:solidFill>
                   <a:srgbClr val="14161C"/>
                 </a:solidFill>
@@ -15190,10 +14948,10 @@
                 <a:ea typeface="Bricolage Grotesque ExtraBold" pitchFamily="34" charset="-122"/>
                 <a:cs typeface="Bricolage Grotesque ExtraBold" pitchFamily="34" charset="-120"/>
               </a:rPr>
-              <a:t> gửi.</a:t>
-            </a:r>
-            <a:r>
-              <a:rPr lang="en-US" sz="5100" dirty="0" spc="-2" kern="0">
+              <a:t> gửi:</a:t>
+            </a:r>
+            <a:r>
+              <a:rPr lang="en-US" sz="5100" dirty="0" spc="0" kern="0">
                 <a:solidFill>
                   <a:srgbClr val="14161C"/>
                 </a:solidFill>
@@ -15201,10 +14959,10 @@
                 <a:ea typeface="Bricolage Grotesque ExtraBold" pitchFamily="34" charset="-122"/>
                 <a:cs typeface="Bricolage Grotesque ExtraBold" pitchFamily="34" charset="-120"/>
               </a:rPr>
-              <a:t> Mở</a:t>
-            </a:r>
-            <a:r>
-              <a:rPr lang="en-US" sz="5100" dirty="0" spc="1" kern="0">
+              <a:t> cuộc</a:t>
+            </a:r>
+            <a:r>
+              <a:rPr lang="en-US" sz="5100" dirty="0" spc="-5" kern="0">
                 <a:solidFill>
                   <a:srgbClr val="14161C"/>
                 </a:solidFill>
@@ -15212,10 +14970,10 @@
                 <a:ea typeface="Bricolage Grotesque ExtraBold" pitchFamily="34" charset="-122"/>
                 <a:cs typeface="Bricolage Grotesque ExtraBold" pitchFamily="34" charset="-120"/>
               </a:rPr>
-              <a:t> cuộc</a:t>
-            </a:r>
-            <a:r>
-              <a:rPr lang="en-US" sz="5100" dirty="0" spc="-4" kern="0">
+              <a:t> An–Bình</a:t>
+            </a:r>
+            <a:r>
+              <a:rPr lang="en-US" sz="5100" dirty="0" spc="-1" kern="0">
                 <a:solidFill>
                   <a:srgbClr val="14161C"/>
                 </a:solidFill>
@@ -15223,76 +14981,10 @@
                 <a:ea typeface="Bricolage Grotesque ExtraBold" pitchFamily="34" charset="-122"/>
                 <a:cs typeface="Bricolage Grotesque ExtraBold" pitchFamily="34" charset="-120"/>
               </a:rPr>
-              <a:t> An</a:t>
-            </a:r>
-            <a:r>
-              <a:rPr lang="en-US" sz="5100" dirty="0" spc="-56" kern="0">
-                <a:solidFill>
-                  <a:srgbClr val="14161C"/>
-                </a:solidFill>
-                <a:latin typeface="Bricolage Grotesque ExtraBold" pitchFamily="34" charset="0"/>
-                <a:ea typeface="Bricolage Grotesque ExtraBold" pitchFamily="34" charset="-122"/>
-                <a:cs typeface="Bricolage Grotesque ExtraBold" pitchFamily="34" charset="-120"/>
-              </a:rPr>
-              <a:t> và</a:t>
-            </a:r>
-            <a:r>
-              <a:rPr lang="en-US" sz="5100" dirty="0" spc="-8" kern="0">
-                <a:solidFill>
-                  <a:srgbClr val="14161C"/>
-                </a:solidFill>
-                <a:latin typeface="Bricolage Grotesque ExtraBold" pitchFamily="34" charset="0"/>
-                <a:ea typeface="Bricolage Grotesque ExtraBold" pitchFamily="34" charset="-122"/>
-                <a:cs typeface="Bricolage Grotesque ExtraBold" pitchFamily="34" charset="-120"/>
-              </a:rPr>
-              <a:t> Bình,</a:t>
-            </a:r>
-            <a:r>
-              <a:rPr lang="en-US" sz="5100" dirty="0" spc="-6" kern="0">
-                <a:solidFill>
-                  <a:srgbClr val="14161C"/>
-                </a:solidFill>
-                <a:latin typeface="Bricolage Grotesque ExtraBold" pitchFamily="34" charset="0"/>
-                <a:ea typeface="Bricolage Grotesque ExtraBold" pitchFamily="34" charset="-122"/>
-                <a:cs typeface="Bricolage Grotesque ExtraBold" pitchFamily="34" charset="-120"/>
-              </a:rPr>
-              <a:t> 50</a:t>
-            </a:r>
-            <a:r>
-              <a:rPr lang="en-US" sz="5100" dirty="0" spc="3" kern="0">
-                <a:solidFill>
-                  <a:srgbClr val="14161C"/>
-                </a:solidFill>
-                <a:latin typeface="Bricolage Grotesque ExtraBold" pitchFamily="34" charset="0"/>
-                <a:ea typeface="Bricolage Grotesque ExtraBold" pitchFamily="34" charset="-122"/>
-                <a:cs typeface="Bricolage Grotesque ExtraBold" pitchFamily="34" charset="-120"/>
-              </a:rPr>
-              <a:t> tin</a:t>
-            </a:r>
-            <a:r>
-              <a:rPr lang="en-US" sz="5100" dirty="0" spc="-26" kern="0">
-                <a:solidFill>
-                  <a:srgbClr val="14161C"/>
-                </a:solidFill>
-                <a:latin typeface="Bricolage Grotesque ExtraBold" pitchFamily="34" charset="0"/>
-                <a:ea typeface="Bricolage Grotesque ExtraBold" pitchFamily="34" charset="-122"/>
-                <a:cs typeface="Bricolage Grotesque ExtraBold" pitchFamily="34" charset="-120"/>
-              </a:rPr>
-              <a:t> mới</a:t>
-            </a:r>
-            <a:r>
-              <a:rPr lang="en-US" sz="5100" dirty="0" spc="7" kern="0">
-                <a:solidFill>
-                  <a:srgbClr val="14161C"/>
-                </a:solidFill>
-                <a:latin typeface="Bricolage Grotesque ExtraBold" pitchFamily="34" charset="0"/>
-                <a:ea typeface="Bricolage Grotesque ExtraBold" pitchFamily="34" charset="-122"/>
-                <a:cs typeface="Bricolage Grotesque ExtraBold" pitchFamily="34" charset="-120"/>
-              </a:rPr>
-              <a:t> nhất:</a:t>
-            </a:r>
-            <a:r>
-              <a:rPr lang="en-US" sz="5100" dirty="0" spc="-2" kern="0">
+              <a:t> chạm</a:t>
+            </a:r>
+            <a:r>
+              <a:rPr lang="en-US" sz="5100" dirty="0" spc="-3" kern="0">
                 <a:solidFill>
                   <a:srgbClr val="14161C"/>
                 </a:solidFill>
@@ -15743,7 +15435,7 @@
               <a:t> sắp</a:t>
             </a:r>
             <a:r>
-              <a:rPr lang="en-US" sz="1950" dirty="0" spc="-2" kern="0">
+              <a:rPr lang="en-US" sz="1950" dirty="0" spc="0" kern="0">
                 <a:solidFill>
                   <a:srgbClr val="6B6A66"/>
                 </a:solidFill>
@@ -15751,10 +15443,10 @@
                 <a:ea typeface="Be Vietnam Pro" pitchFamily="34" charset="-122"/>
                 <a:cs typeface="Be Vietnam Pro" pitchFamily="34" charset="-120"/>
               </a:rPr>
-              <a:t> theo</a:t>
-            </a:r>
-            <a:r>
-              <a:rPr lang="en-US" sz="1950" dirty="0" spc="-1" kern="0">
+              <a:t> lại; mỗi</a:t>
+            </a:r>
+            <a:r>
+              <a:rPr lang="en-US" sz="1950" dirty="0" spc="-13" kern="0">
                 <a:solidFill>
                   <a:srgbClr val="6B6A66"/>
                 </a:solidFill>
@@ -15762,10 +15454,10 @@
                 <a:ea typeface="Be Vietnam Pro" pitchFamily="34" charset="-122"/>
                 <a:cs typeface="Be Vietnam Pro" pitchFamily="34" charset="-120"/>
               </a:rPr>
-              <a:t> thời</a:t>
-            </a:r>
-            <a:r>
-              <a:rPr lang="en-US" sz="1950" dirty="0" spc="3" kern="0">
+              <a:t> shard</a:t>
+            </a:r>
+            <a:r>
+              <a:rPr lang="en-US" sz="1950" dirty="0" spc="-20" kern="0">
                 <a:solidFill>
                   <a:srgbClr val="6B6A66"/>
                 </a:solidFill>
@@ -15773,10 +15465,10 @@
                 <a:ea typeface="Be Vietnam Pro" pitchFamily="34" charset="-122"/>
                 <a:cs typeface="Be Vietnam Pro" pitchFamily="34" charset="-120"/>
               </a:rPr>
-              <a:t> gian;</a:t>
-            </a:r>
-            <a:r>
-              <a:rPr lang="en-US" sz="1950" dirty="0" spc="0" kern="0">
+              <a:t> trả</a:t>
+            </a:r>
+            <a:r>
+              <a:rPr lang="en-US" sz="1950" dirty="0" spc="1" kern="0">
                 <a:solidFill>
                   <a:srgbClr val="6B6A66"/>
                 </a:solidFill>
@@ -15784,51 +15476,7 @@
                 <a:ea typeface="Be Vietnam Pro" pitchFamily="34" charset="-122"/>
                 <a:cs typeface="Be Vietnam Pro" pitchFamily="34" charset="-120"/>
               </a:rPr>
-              <a:t> mỗi</a:t>
-            </a:r>
-            <a:r>
-              <a:rPr lang="en-US" sz="1950" dirty="0" spc="-13" kern="0">
-                <a:solidFill>
-                  <a:srgbClr val="6B6A66"/>
-                </a:solidFill>
-                <a:latin typeface="Be Vietnam Pro" pitchFamily="34" charset="0"/>
-                <a:ea typeface="Be Vietnam Pro" pitchFamily="34" charset="-122"/>
-                <a:cs typeface="Be Vietnam Pro" pitchFamily="34" charset="-120"/>
-              </a:rPr>
-              <a:t> shard</a:t>
-            </a:r>
-            <a:r>
-              <a:rPr lang="en-US" sz="1950" dirty="0" spc="-21" kern="0">
-                <a:solidFill>
-                  <a:srgbClr val="6B6A66"/>
-                </a:solidFill>
-                <a:latin typeface="Be Vietnam Pro" pitchFamily="34" charset="0"/>
-                <a:ea typeface="Be Vietnam Pro" pitchFamily="34" charset="-122"/>
-                <a:cs typeface="Be Vietnam Pro" pitchFamily="34" charset="-120"/>
-              </a:rPr>
-              <a:t> trả</a:t>
-            </a:r>
-            <a:r>
-              <a:rPr lang="en-US" sz="1950" dirty="0" spc="2" kern="0">
-                <a:solidFill>
-                  <a:srgbClr val="6B6A66"/>
-                </a:solidFill>
-                <a:latin typeface="Be Vietnam Pro" pitchFamily="34" charset="0"/>
-                <a:ea typeface="Be Vietnam Pro" pitchFamily="34" charset="-122"/>
-                <a:cs typeface="Be Vietnam Pro" pitchFamily="34" charset="-120"/>
-              </a:rPr>
-              <a:t> đủ</a:t>
-            </a:r>
-            <a:r>
-              <a:rPr lang="en-US" sz="1950" dirty="0" spc="1" kern="0">
-                <a:solidFill>
-                  <a:srgbClr val="6B6A66"/>
-                </a:solidFill>
-                <a:latin typeface="Be Vietnam Pro" pitchFamily="34" charset="0"/>
-                <a:ea typeface="Be Vietnam Pro" pitchFamily="34" charset="-122"/>
-                <a:cs typeface="Be Vietnam Pro" pitchFamily="34" charset="-120"/>
-              </a:rPr>
-              <a:t> 50</a:t>
+              <a:t> đủ 50</a:t>
             </a:r>
             <a:endParaRPr lang="en-US" sz="1950" dirty="0"/>
           </a:p>

</xml_diff>

<commit_message>
Slides: cover titles at 108 px, slide titles at 92 to 112 px (sd-04-036..038)
Co-Authored-By: Claude Opus 5.5 <noreply@anthropic.com>
Claude-Session: https://claude.ai/code/session_01JWtUsCyy9ESaq4agyTKnFb
</commit_message>
<xml_diff>
--- a/system-design-101/vi/lessons/sd-04-036/slides/sd-04-036.pptx
+++ b/system-design-101/vi/lessons/sd-04-036/slides/sd-04-036.pptx
@@ -1790,7 +1790,7 @@
         <p:spPr>
           <a:xfrm>
             <a:off x="914400" y="1428750"/>
-            <a:ext cx="9144000" cy="1685925"/>
+            <a:ext cx="9144000" cy="2286000"/>
           </a:xfrm>
           <a:prstGeom prst="rect">
             <a:avLst/>
@@ -1799,17 +1799,17 @@
           <a:ln/>
         </p:spPr>
         <p:txBody>
-          <a:bodyPr wrap="square" lIns="0" tIns="60420" rIns="0" bIns="-60420" rtlCol="0" anchor="t"/>
+          <a:bodyPr wrap="square" lIns="0" tIns="69437" rIns="0" bIns="-69437" rtlCol="0" anchor="t"/>
           <a:lstStyle/>
           <a:p>
             <a:pPr algn="l" indent="0" marL="0">
               <a:lnSpc>
-                <a:spcPts val="7403"/>
+                <a:spcPts val="8505"/>
               </a:lnSpc>
               <a:buNone/>
             </a:pPr>
             <a:r>
-              <a:rPr lang="en-US" sz="7050" dirty="0" spc="1" kern="0">
+              <a:rPr lang="en-US" sz="8100" dirty="0" spc="-1" kern="0">
                 <a:solidFill>
                   <a:srgbClr val="F3EEE3"/>
                 </a:solidFill>
@@ -1817,10 +1817,10 @@
                 <a:ea typeface="Bricolage Grotesque ExtraBold" pitchFamily="34" charset="-122"/>
                 <a:cs typeface="Bricolage Grotesque ExtraBold" pitchFamily="34" charset="-120"/>
               </a:rPr>
-              <a:t>Nhập môn</a:t>
-            </a:r>
-            <a:r>
-              <a:rPr lang="en-US" sz="7050" dirty="0" spc="-7" kern="0">
+              <a:t>Nhập</a:t>
+            </a:r>
+            <a:r>
+              <a:rPr lang="en-US" sz="8100" dirty="0" spc="1" kern="0">
                 <a:solidFill>
                   <a:srgbClr val="F3EEE3"/>
                 </a:solidFill>
@@ -1828,9 +1828,20 @@
                 <a:ea typeface="Bricolage Grotesque ExtraBold" pitchFamily="34" charset="-122"/>
                 <a:cs typeface="Bricolage Grotesque ExtraBold" pitchFamily="34" charset="-120"/>
               </a:rPr>
+              <a:t> môn</a:t>
+            </a:r>
+            <a:r>
+              <a:rPr lang="en-US" sz="8100" dirty="0" spc="-8" kern="0">
+                <a:solidFill>
+                  <a:srgbClr val="F3EEE3"/>
+                </a:solidFill>
+                <a:latin typeface="Bricolage Grotesque ExtraBold" pitchFamily="34" charset="0"/>
+                <a:ea typeface="Bricolage Grotesque ExtraBold" pitchFamily="34" charset="-122"/>
+                <a:cs typeface="Bricolage Grotesque ExtraBold" pitchFamily="34" charset="-120"/>
+              </a:rPr>
               <a:t> sharding</a:t>
             </a:r>
-            <a:endParaRPr lang="en-US" sz="7050" dirty="0"/>
+            <a:endParaRPr lang="en-US" sz="8100" dirty="0"/>
           </a:p>
         </p:txBody>
       </p:sp>
@@ -5982,7 +5993,7 @@
         <p:spPr>
           <a:xfrm>
             <a:off x="914400" y="1333500"/>
-            <a:ext cx="16459200" cy="1238250"/>
+            <a:ext cx="16459200" cy="1143000"/>
           </a:xfrm>
           <a:prstGeom prst="rect">
             <a:avLst/>
@@ -5998,7 +6009,7 @@
               <a:buNone/>
             </a:pPr>
             <a:r>
-              <a:rPr lang="en-US" sz="6300" dirty="0" spc="4" kern="0">
+              <a:rPr lang="en-US" sz="6900" dirty="0" spc="-9" kern="0">
                 <a:solidFill>
                   <a:srgbClr val="14161C"/>
                 </a:solidFill>
@@ -6006,10 +6017,10 @@
                 <a:ea typeface="Bricolage Grotesque ExtraBold" pitchFamily="34" charset="-122"/>
                 <a:cs typeface="Bricolage Grotesque ExtraBold" pitchFamily="34" charset="-120"/>
               </a:rPr>
-              <a:t>Chọn</a:t>
-            </a:r>
-            <a:r>
-              <a:rPr lang="en-US" sz="6300" dirty="0" spc="-7" kern="0">
+              <a:t>Khóa shard</a:t>
+            </a:r>
+            <a:r>
+              <a:rPr lang="en-US" sz="6900" dirty="0" spc="1" kern="0">
                 <a:solidFill>
                   <a:srgbClr val="14161C"/>
                 </a:solidFill>
@@ -6017,10 +6028,10 @@
                 <a:ea typeface="Bricolage Grotesque ExtraBold" pitchFamily="34" charset="-122"/>
                 <a:cs typeface="Bricolage Grotesque ExtraBold" pitchFamily="34" charset="-120"/>
               </a:rPr>
-              <a:t> khóa</a:t>
-            </a:r>
-            <a:r>
-              <a:rPr lang="en-US" sz="6300" dirty="0" spc="-9" kern="0">
+              <a:t> quyết</a:t>
+            </a:r>
+            <a:r>
+              <a:rPr lang="en-US" sz="6900" dirty="0" spc="23" kern="0">
                 <a:solidFill>
                   <a:srgbClr val="14161C"/>
                 </a:solidFill>
@@ -6028,10 +6039,10 @@
                 <a:ea typeface="Bricolage Grotesque ExtraBold" pitchFamily="34" charset="-122"/>
                 <a:cs typeface="Bricolage Grotesque ExtraBold" pitchFamily="34" charset="-120"/>
               </a:rPr>
-              <a:t> shard</a:t>
-            </a:r>
-            <a:r>
-              <a:rPr lang="en-US" sz="6300" dirty="0" spc="-1" kern="0">
+              <a:t> định</a:t>
+            </a:r>
+            <a:r>
+              <a:rPr lang="en-US" sz="6900" dirty="0" spc="-1" kern="0">
                 <a:solidFill>
                   <a:srgbClr val="14161C"/>
                 </a:solidFill>
@@ -6039,10 +6050,10 @@
                 <a:ea typeface="Bricolage Grotesque ExtraBold" pitchFamily="34" charset="-122"/>
                 <a:cs typeface="Bricolage Grotesque ExtraBold" pitchFamily="34" charset="-120"/>
               </a:rPr>
-              <a:t> là</a:t>
-            </a:r>
-            <a:r>
-              <a:rPr lang="en-US" sz="6300" dirty="0" spc="1" kern="0">
+              <a:t> câu</a:t>
+            </a:r>
+            <a:r>
+              <a:rPr lang="en-US" sz="6900" dirty="0" spc="2" kern="0">
                 <a:solidFill>
                   <a:srgbClr val="14161C"/>
                 </a:solidFill>
@@ -6050,10 +6061,10 @@
                 <a:ea typeface="Bricolage Grotesque ExtraBold" pitchFamily="34" charset="-122"/>
                 <a:cs typeface="Bricolage Grotesque ExtraBold" pitchFamily="34" charset="-120"/>
               </a:rPr>
-              <a:t> chọn</a:t>
-            </a:r>
-            <a:r>
-              <a:rPr lang="en-US" sz="6300" dirty="0" spc="-2" kern="0">
+              <a:t> nào</a:t>
+            </a:r>
+            <a:r>
+              <a:rPr lang="en-US" sz="6900" dirty="0" spc="-27" kern="0">
                 <a:solidFill>
                   <a:srgbClr val="14161C"/>
                 </a:solidFill>
@@ -6061,31 +6072,9 @@
                 <a:ea typeface="Bricolage Grotesque ExtraBold" pitchFamily="34" charset="-122"/>
                 <a:cs typeface="Bricolage Grotesque ExtraBold" pitchFamily="34" charset="-120"/>
               </a:rPr>
-              <a:t> câu</a:t>
-            </a:r>
-            <a:r>
-              <a:rPr lang="en-US" sz="6300" dirty="0" spc="1" kern="0">
-                <a:solidFill>
-                  <a:srgbClr val="14161C"/>
-                </a:solidFill>
-                <a:latin typeface="Bricolage Grotesque ExtraBold" pitchFamily="34" charset="0"/>
-                <a:ea typeface="Bricolage Grotesque ExtraBold" pitchFamily="34" charset="-122"/>
-                <a:cs typeface="Bricolage Grotesque ExtraBold" pitchFamily="34" charset="-120"/>
-              </a:rPr>
-              <a:t> hỏi nào</a:t>
-            </a:r>
-            <a:r>
-              <a:rPr lang="en-US" sz="6300" dirty="0" spc="-27" kern="0">
-                <a:solidFill>
-                  <a:srgbClr val="14161C"/>
-                </a:solidFill>
-                <a:latin typeface="Bricolage Grotesque ExtraBold" pitchFamily="34" charset="0"/>
-                <a:ea typeface="Bricolage Grotesque ExtraBold" pitchFamily="34" charset="-122"/>
-                <a:cs typeface="Bricolage Grotesque ExtraBold" pitchFamily="34" charset="-120"/>
-              </a:rPr>
               <a:t> rẻ</a:t>
             </a:r>
-            <a:endParaRPr lang="en-US" sz="6300" dirty="0"/>
+            <a:endParaRPr lang="en-US" sz="6900" dirty="0"/>
           </a:p>
         </p:txBody>
       </p:sp>
@@ -8264,7 +8253,7 @@
               <a:buNone/>
             </a:pPr>
             <a:r>
-              <a:rPr lang="en-US" sz="6000" dirty="0" spc="-15" kern="0">
+              <a:rPr lang="en-US" sz="6900" dirty="0" spc="-14" kern="0">
                 <a:solidFill>
                   <a:srgbClr val="F3EEE3"/>
                 </a:solidFill>
@@ -8275,7 +8264,7 @@
               <a:t>Một</a:t>
             </a:r>
             <a:r>
-              <a:rPr lang="en-US" sz="6000" dirty="0" spc="-1" kern="0">
+              <a:rPr lang="en-US" sz="6900" dirty="0" spc="0" kern="0">
                 <a:solidFill>
                   <a:srgbClr val="F3EEE3"/>
                 </a:solidFill>
@@ -8286,7 +8275,7 @@
               <a:t> khách</a:t>
             </a:r>
             <a:r>
-              <a:rPr lang="en-US" sz="6000" dirty="0" spc="-37" kern="0">
+              <a:rPr lang="en-US" sz="6900" dirty="0" spc="-35" kern="0">
                 <a:solidFill>
                   <a:srgbClr val="F3EEE3"/>
                 </a:solidFill>
@@ -8294,10 +8283,10 @@
                 <a:ea typeface="Bricolage Grotesque ExtraBold" pitchFamily="34" charset="-122"/>
                 <a:cs typeface="Bricolage Grotesque ExtraBold" pitchFamily="34" charset="-120"/>
               </a:rPr>
-              <a:t> lớn</a:t>
-            </a:r>
-            <a:r>
-              <a:rPr lang="en-US" sz="6000" dirty="0" spc="1" kern="0">
+              <a:t> lớn,</a:t>
+            </a:r>
+            <a:r>
+              <a:rPr lang="en-US" sz="6900" dirty="0" spc="-1" kern="0">
                 <a:solidFill>
                   <a:srgbClr val="F3EEE3"/>
                 </a:solidFill>
@@ -8305,10 +8294,10 @@
                 <a:ea typeface="Bricolage Grotesque ExtraBold" pitchFamily="34" charset="-122"/>
                 <a:cs typeface="Bricolage Grotesque ExtraBold" pitchFamily="34" charset="-120"/>
               </a:rPr>
-              <a:t> làm cả</a:t>
-            </a:r>
-            <a:r>
-              <a:rPr lang="en-US" sz="6000" dirty="0" spc="-7" kern="0">
+              <a:t> cả</a:t>
+            </a:r>
+            <a:r>
+              <a:rPr lang="en-US" sz="6900" dirty="0" spc="-9" kern="0">
                 <a:solidFill>
                   <a:srgbClr val="F3EEE3"/>
                 </a:solidFill>
@@ -8319,7 +8308,7 @@
               <a:t> shard</a:t>
             </a:r>
             <a:r>
-              <a:rPr lang="en-US" sz="6000" dirty="0" spc="-1" kern="0">
+              <a:rPr lang="en-US" sz="6900" dirty="0" spc="2" kern="0">
                 <a:solidFill>
                   <a:srgbClr val="F3EEE3"/>
                 </a:solidFill>
@@ -8330,7 +8319,7 @@
               <a:t> nặng</a:t>
             </a:r>
             <a:r>
-              <a:rPr lang="en-US" sz="6000" dirty="0" spc="-13" kern="0">
+              <a:rPr lang="en-US" sz="6900" dirty="0" spc="-12" kern="0">
                 <a:solidFill>
                   <a:srgbClr val="F3EEE3"/>
                 </a:solidFill>
@@ -8341,7 +8330,7 @@
               <a:t> gấp</a:t>
             </a:r>
             <a:r>
-              <a:rPr lang="en-US" sz="6000" dirty="0" spc="14" kern="0">
+              <a:rPr lang="en-US" sz="6900" dirty="0" spc="13" kern="0">
                 <a:solidFill>
                   <a:srgbClr val="F3EEE3"/>
                 </a:solidFill>
@@ -8351,7 +8340,7 @@
               </a:rPr>
               <a:t> đôi</a:t>
             </a:r>
-            <a:endParaRPr lang="en-US" sz="6000" dirty="0"/>
+            <a:endParaRPr lang="en-US" sz="6900" dirty="0"/>
           </a:p>
         </p:txBody>
       </p:sp>
@@ -9690,7 +9679,7 @@
               <a:buNone/>
             </a:pPr>
             <a:r>
-              <a:rPr lang="en-US" sz="6000" dirty="0" spc="-17" kern="0">
+              <a:rPr lang="en-US" sz="6900" dirty="0" spc="1" kern="0">
                 <a:solidFill>
                   <a:srgbClr val="14161C"/>
                 </a:solidFill>
@@ -9698,10 +9687,10 @@
                 <a:ea typeface="Bricolage Grotesque ExtraBold" pitchFamily="34" charset="-122"/>
                 <a:cs typeface="Bricolage Grotesque ExtraBold" pitchFamily="34" charset="-120"/>
               </a:rPr>
-              <a:t>Trung</a:t>
-            </a:r>
-            <a:r>
-              <a:rPr lang="en-US" sz="6000" dirty="0" spc="-16" kern="0">
+              <a:t>Không</a:t>
+            </a:r>
+            <a:r>
+              <a:rPr lang="en-US" sz="6900" dirty="0" spc="-2" kern="0">
                 <a:solidFill>
                   <a:srgbClr val="14161C"/>
                 </a:solidFill>
@@ -9709,10 +9698,10 @@
                 <a:ea typeface="Bricolage Grotesque ExtraBold" pitchFamily="34" charset="-122"/>
                 <a:cs typeface="Bricolage Grotesque ExtraBold" pitchFamily="34" charset="-120"/>
               </a:rPr>
-              <a:t> bình</a:t>
-            </a:r>
-            <a:r>
-              <a:rPr lang="en-US" sz="6000" dirty="0" spc="0" kern="0">
+              <a:t> lấy</a:t>
+            </a:r>
+            <a:r>
+              <a:rPr lang="en-US" sz="6900" dirty="0" spc="7" kern="0">
                 <a:solidFill>
                   <a:srgbClr val="14161C"/>
                 </a:solidFill>
@@ -9720,10 +9709,10 @@
                 <a:ea typeface="Bricolage Grotesque ExtraBold" pitchFamily="34" charset="-122"/>
                 <a:cs typeface="Bricolage Grotesque ExtraBold" pitchFamily="34" charset="-120"/>
               </a:rPr>
-              <a:t> các</a:t>
-            </a:r>
-            <a:r>
-              <a:rPr lang="en-US" sz="6000" dirty="0" spc="4" kern="0">
+              <a:t> trung</a:t>
+            </a:r>
+            <a:r>
+              <a:rPr lang="en-US" sz="6900" dirty="0" spc="-17" kern="0">
                 <a:solidFill>
                   <a:srgbClr val="14161C"/>
                 </a:solidFill>
@@ -9731,10 +9720,10 @@
                 <a:ea typeface="Bricolage Grotesque ExtraBold" pitchFamily="34" charset="-122"/>
                 <a:cs typeface="Bricolage Grotesque ExtraBold" pitchFamily="34" charset="-120"/>
               </a:rPr>
-              <a:t> trung</a:t>
-            </a:r>
-            <a:r>
-              <a:rPr lang="en-US" sz="6000" dirty="0" spc="-15" kern="0">
+              <a:t> bình</a:t>
+            </a:r>
+            <a:r>
+              <a:rPr lang="en-US" sz="6900" dirty="0" spc="-2" kern="0">
                 <a:solidFill>
                   <a:srgbClr val="14161C"/>
                 </a:solidFill>
@@ -9742,10 +9731,10 @@
                 <a:ea typeface="Bricolage Grotesque ExtraBold" pitchFamily="34" charset="-122"/>
                 <a:cs typeface="Bricolage Grotesque ExtraBold" pitchFamily="34" charset="-120"/>
               </a:rPr>
-              <a:t> bình</a:t>
-            </a:r>
-            <a:r>
-              <a:rPr lang="en-US" sz="6000" dirty="0" spc="-2" kern="0">
+              <a:t> các</a:t>
+            </a:r>
+            <a:r>
+              <a:rPr lang="en-US" sz="6900" dirty="0" spc="7" kern="0">
                 <a:solidFill>
                   <a:srgbClr val="14161C"/>
                 </a:solidFill>
@@ -9753,10 +9742,10 @@
                 <a:ea typeface="Bricolage Grotesque ExtraBold" pitchFamily="34" charset="-122"/>
                 <a:cs typeface="Bricolage Grotesque ExtraBold" pitchFamily="34" charset="-120"/>
               </a:rPr>
-              <a:t> không</a:t>
-            </a:r>
-            <a:r>
-              <a:rPr lang="en-US" sz="6000" dirty="0" spc="3" kern="0">
+              <a:t> trung</a:t>
+            </a:r>
+            <a:r>
+              <a:rPr lang="en-US" sz="6900" dirty="0" spc="-18" kern="0">
                 <a:solidFill>
                   <a:srgbClr val="14161C"/>
                 </a:solidFill>
@@ -9764,31 +9753,9 @@
                 <a:ea typeface="Bricolage Grotesque ExtraBold" pitchFamily="34" charset="-122"/>
                 <a:cs typeface="Bricolage Grotesque ExtraBold" pitchFamily="34" charset="-120"/>
               </a:rPr>
-              <a:t> phải</a:t>
-            </a:r>
-            <a:r>
-              <a:rPr lang="en-US" sz="6000" dirty="0" spc="4" kern="0">
-                <a:solidFill>
-                  <a:srgbClr val="14161C"/>
-                </a:solidFill>
-                <a:latin typeface="Bricolage Grotesque ExtraBold" pitchFamily="34" charset="0"/>
-                <a:ea typeface="Bricolage Grotesque ExtraBold" pitchFamily="34" charset="-122"/>
-                <a:cs typeface="Bricolage Grotesque ExtraBold" pitchFamily="34" charset="-120"/>
-              </a:rPr>
-              <a:t> trung</a:t>
-            </a:r>
-            <a:r>
-              <a:rPr lang="en-US" sz="6000" dirty="0" spc="-15" kern="0">
-                <a:solidFill>
-                  <a:srgbClr val="14161C"/>
-                </a:solidFill>
-                <a:latin typeface="Bricolage Grotesque ExtraBold" pitchFamily="34" charset="0"/>
-                <a:ea typeface="Bricolage Grotesque ExtraBold" pitchFamily="34" charset="-122"/>
-                <a:cs typeface="Bricolage Grotesque ExtraBold" pitchFamily="34" charset="-120"/>
-              </a:rPr>
               <a:t> bình</a:t>
             </a:r>
-            <a:endParaRPr lang="en-US" sz="6000" dirty="0"/>
+            <a:endParaRPr lang="en-US" sz="6900" dirty="0"/>
           </a:p>
         </p:txBody>
       </p:sp>
@@ -11197,7 +11164,7 @@
               <a:buNone/>
             </a:pPr>
             <a:r>
-              <a:rPr lang="en-US" sz="6000" dirty="0" spc="2" kern="0">
+              <a:rPr lang="en-US" sz="6900" dirty="0" spc="7" kern="0">
                 <a:solidFill>
                   <a:srgbClr val="14161C"/>
                 </a:solidFill>
@@ -11208,7 +11175,7 @@
               <a:t>Chuyển</a:t>
             </a:r>
             <a:r>
-              <a:rPr lang="en-US" sz="6000" dirty="0" spc="12" kern="0">
+              <a:rPr lang="en-US" sz="6900" dirty="0" spc="9" kern="0">
                 <a:solidFill>
                   <a:srgbClr val="14161C"/>
                 </a:solidFill>
@@ -11219,7 +11186,7 @@
               <a:t> 30</a:t>
             </a:r>
             <a:r>
-              <a:rPr lang="en-US" sz="6000" dirty="0" spc="2" kern="0">
+              <a:rPr lang="en-US" sz="6900" dirty="0" spc="-1" kern="0">
                 <a:solidFill>
                   <a:srgbClr val="14161C"/>
                 </a:solidFill>
@@ -11227,10 +11194,10 @@
                 <a:ea typeface="Bricolage Grotesque ExtraBold" pitchFamily="34" charset="-122"/>
                 <a:cs typeface="Bricolage Grotesque ExtraBold" pitchFamily="34" charset="-120"/>
               </a:rPr>
-              <a:t> là hai</a:t>
-            </a:r>
-            <a:r>
-              <a:rPr lang="en-US" sz="6000" dirty="0" spc="0" kern="0">
+              <a:t> là</a:t>
+            </a:r>
+            <a:r>
+              <a:rPr lang="en-US" sz="6900" dirty="0" spc="3" kern="0">
                 <a:solidFill>
                   <a:srgbClr val="14161C"/>
                 </a:solidFill>
@@ -11238,10 +11205,10 @@
                 <a:ea typeface="Bricolage Grotesque ExtraBold" pitchFamily="34" charset="-122"/>
                 <a:cs typeface="Bricolage Grotesque ExtraBold" pitchFamily="34" charset="-120"/>
               </a:rPr>
-              <a:t> lần ghi</a:t>
-            </a:r>
-            <a:r>
-              <a:rPr lang="en-US" sz="6000" dirty="0" spc="2" kern="0">
+              <a:t> hai</a:t>
+            </a:r>
+            <a:r>
+              <a:rPr lang="en-US" sz="6900" dirty="0" spc="0" kern="0">
                 <a:solidFill>
                   <a:srgbClr val="14161C"/>
                 </a:solidFill>
@@ -11249,10 +11216,10 @@
                 <a:ea typeface="Bricolage Grotesque ExtraBold" pitchFamily="34" charset="-122"/>
                 <a:cs typeface="Bricolage Grotesque ExtraBold" pitchFamily="34" charset="-120"/>
               </a:rPr>
-              <a:t> ở hai</a:t>
-            </a:r>
-            <a:r>
-              <a:rPr lang="en-US" sz="6000" dirty="0" spc="-7" kern="0">
+              <a:t> lần</a:t>
+            </a:r>
+            <a:r>
+              <a:rPr lang="en-US" sz="6900" dirty="0" spc="2" kern="0">
                 <a:solidFill>
                   <a:srgbClr val="14161C"/>
                 </a:solidFill>
@@ -11260,9 +11227,42 @@
                 <a:ea typeface="Bricolage Grotesque ExtraBold" pitchFamily="34" charset="-122"/>
                 <a:cs typeface="Bricolage Grotesque ExtraBold" pitchFamily="34" charset="-120"/>
               </a:rPr>
+              <a:t> ghi</a:t>
+            </a:r>
+            <a:r>
+              <a:rPr lang="en-US" sz="6900" dirty="0" spc="-1" kern="0">
+                <a:solidFill>
+                  <a:srgbClr val="14161C"/>
+                </a:solidFill>
+                <a:latin typeface="Bricolage Grotesque ExtraBold" pitchFamily="34" charset="0"/>
+                <a:ea typeface="Bricolage Grotesque ExtraBold" pitchFamily="34" charset="-122"/>
+                <a:cs typeface="Bricolage Grotesque ExtraBold" pitchFamily="34" charset="-120"/>
+              </a:rPr>
+              <a:t> ở</a:t>
+            </a:r>
+            <a:r>
+              <a:rPr lang="en-US" sz="6900" dirty="0" spc="2" kern="0">
+                <a:solidFill>
+                  <a:srgbClr val="14161C"/>
+                </a:solidFill>
+                <a:latin typeface="Bricolage Grotesque ExtraBold" pitchFamily="34" charset="0"/>
+                <a:ea typeface="Bricolage Grotesque ExtraBold" pitchFamily="34" charset="-122"/>
+                <a:cs typeface="Bricolage Grotesque ExtraBold" pitchFamily="34" charset="-120"/>
+              </a:rPr>
+              <a:t> hai</a:t>
+            </a:r>
+            <a:r>
+              <a:rPr lang="en-US" sz="6900" dirty="0" spc="-9" kern="0">
+                <a:solidFill>
+                  <a:srgbClr val="14161C"/>
+                </a:solidFill>
+                <a:latin typeface="Bricolage Grotesque ExtraBold" pitchFamily="34" charset="0"/>
+                <a:ea typeface="Bricolage Grotesque ExtraBold" pitchFamily="34" charset="-122"/>
+                <a:cs typeface="Bricolage Grotesque ExtraBold" pitchFamily="34" charset="-120"/>
+              </a:rPr>
               <a:t> shard</a:t>
             </a:r>
-            <a:endParaRPr lang="en-US" sz="6000" dirty="0"/>
+            <a:endParaRPr lang="en-US" sz="6900" dirty="0"/>
           </a:p>
         </p:txBody>
       </p:sp>
@@ -13116,7 +13116,7 @@
               <a:buNone/>
             </a:pPr>
             <a:r>
-              <a:rPr lang="en-US" sz="6000" dirty="0" spc="1" kern="0">
+              <a:rPr lang="en-US" sz="6900" dirty="0" spc="6" kern="0">
                 <a:solidFill>
                   <a:srgbClr val="F3EEE3"/>
                 </a:solidFill>
@@ -13127,7 +13127,7 @@
               <a:t>Phép</a:t>
             </a:r>
             <a:r>
-              <a:rPr lang="en-US" sz="6000" dirty="0" spc="-1" kern="0">
+              <a:rPr lang="en-US" sz="6900" dirty="0" spc="1" kern="0">
                 <a:solidFill>
                   <a:srgbClr val="F3EEE3"/>
                 </a:solidFill>
@@ -13135,10 +13135,10 @@
                 <a:ea typeface="Bricolage Grotesque ExtraBold" pitchFamily="34" charset="-122"/>
                 <a:cs typeface="Bricolage Grotesque ExtraBold" pitchFamily="34" charset="-120"/>
               </a:rPr>
-              <a:t> thử không</a:t>
-            </a:r>
-            <a:r>
-              <a:rPr lang="en-US" sz="6000" dirty="0" spc="-3" kern="0">
+              <a:t> thử</a:t>
+            </a:r>
+            <a:r>
+              <a:rPr lang="en-US" sz="6900" dirty="0" spc="0" kern="0">
                 <a:solidFill>
                   <a:srgbClr val="F3EEE3"/>
                 </a:solidFill>
@@ -13146,10 +13146,10 @@
                 <a:ea typeface="Bricolage Grotesque ExtraBold" pitchFamily="34" charset="-122"/>
                 <a:cs typeface="Bricolage Grotesque ExtraBold" pitchFamily="34" charset="-120"/>
               </a:rPr>
-              <a:t> thấy</a:t>
-            </a:r>
-            <a:r>
-              <a:rPr lang="en-US" sz="6000" dirty="0" spc="-1" kern="0">
+              <a:t> không</a:t>
+            </a:r>
+            <a:r>
+              <a:rPr lang="en-US" sz="6900" dirty="0" spc="-1" kern="0">
                 <a:solidFill>
                   <a:srgbClr val="F3EEE3"/>
                 </a:solidFill>
@@ -13157,10 +13157,10 @@
                 <a:ea typeface="Bricolage Grotesque ExtraBold" pitchFamily="34" charset="-122"/>
                 <a:cs typeface="Bricolage Grotesque ExtraBold" pitchFamily="34" charset="-120"/>
               </a:rPr>
-              <a:t> hết</a:t>
-            </a:r>
-            <a:r>
-              <a:rPr lang="en-US" sz="6000" dirty="0" spc="3" kern="0">
+              <a:t> thấy</a:t>
+            </a:r>
+            <a:r>
+              <a:rPr lang="en-US" sz="6900" dirty="0" spc="3" kern="0">
                 <a:solidFill>
                   <a:srgbClr val="F3EEE3"/>
                 </a:solidFill>
@@ -13168,10 +13168,10 @@
                 <a:ea typeface="Bricolage Grotesque ExtraBold" pitchFamily="34" charset="-122"/>
                 <a:cs typeface="Bricolage Grotesque ExtraBold" pitchFamily="34" charset="-120"/>
               </a:rPr>
-              <a:t> mọi</a:t>
-            </a:r>
-            <a:r>
-              <a:rPr lang="en-US" sz="6000" dirty="0" spc="-1" kern="0">
+              <a:t> hết</a:t>
+            </a:r>
+            <a:r>
+              <a:rPr lang="en-US" sz="6900" dirty="0" spc="0" kern="0">
                 <a:solidFill>
                   <a:srgbClr val="F3EEE3"/>
                 </a:solidFill>
@@ -13179,9 +13179,9 @@
                 <a:ea typeface="Bricolage Grotesque ExtraBold" pitchFamily="34" charset="-122"/>
                 <a:cs typeface="Bricolage Grotesque ExtraBold" pitchFamily="34" charset="-120"/>
               </a:rPr>
-              <a:t> thứ</a:t>
-            </a:r>
-            <a:endParaRPr lang="en-US" sz="6000" dirty="0"/>
+              <a:t> mọi thứ</a:t>
+            </a:r>
+            <a:endParaRPr lang="en-US" sz="6900" dirty="0"/>
           </a:p>
         </p:txBody>
       </p:sp>
@@ -14888,7 +14888,7 @@
         <p:spPr>
           <a:xfrm>
             <a:off x="914400" y="1333500"/>
-            <a:ext cx="16459200" cy="1809750"/>
+            <a:ext cx="16459200" cy="1143000"/>
           </a:xfrm>
           <a:prstGeom prst="rect">
             <a:avLst/>
@@ -14897,17 +14897,17 @@
           <a:ln/>
         </p:spPr>
         <p:txBody>
-          <a:bodyPr wrap="square" lIns="0" tIns="32385" rIns="0" bIns="-32385" rtlCol="0" anchor="t"/>
+          <a:bodyPr wrap="square" lIns="0" tIns="43815" rIns="0" bIns="-43815" rtlCol="0" anchor="t"/>
           <a:lstStyle/>
           <a:p>
             <a:pPr algn="l" indent="0" marL="0">
               <a:lnSpc>
-                <a:spcPts val="5610"/>
+                <a:spcPts val="7590"/>
               </a:lnSpc>
               <a:buNone/>
             </a:pPr>
             <a:r>
-              <a:rPr lang="en-US" sz="5100" dirty="0" spc="5" kern="0">
+              <a:rPr lang="en-US" sz="6900" dirty="0" spc="5" kern="0">
                 <a:solidFill>
                   <a:srgbClr val="14161C"/>
                 </a:solidFill>
@@ -14918,7 +14918,7 @@
               <a:t>Chia</a:t>
             </a:r>
             <a:r>
-              <a:rPr lang="en-US" sz="5100" dirty="0" spc="2" kern="0">
+              <a:rPr lang="en-US" sz="6900" dirty="0" spc="2" kern="0">
                 <a:solidFill>
                   <a:srgbClr val="14161C"/>
                 </a:solidFill>
@@ -14929,7 +14929,7 @@
               <a:t> theo</a:t>
             </a:r>
             <a:r>
-              <a:rPr lang="en-US" sz="5100" dirty="0" spc="-48" kern="0">
+              <a:rPr lang="en-US" sz="6900" dirty="0" spc="-66" kern="0">
                 <a:solidFill>
                   <a:srgbClr val="14161C"/>
                 </a:solidFill>
@@ -14940,7 +14940,7 @@
               <a:t> người</a:t>
             </a:r>
             <a:r>
-              <a:rPr lang="en-US" sz="5100" dirty="0" spc="21" kern="0">
+              <a:rPr lang="en-US" sz="6900" dirty="0" spc="28" kern="0">
                 <a:solidFill>
                   <a:srgbClr val="14161C"/>
                 </a:solidFill>
@@ -14951,7 +14951,7 @@
               <a:t> gửi:</a:t>
             </a:r>
             <a:r>
-              <a:rPr lang="en-US" sz="5100" dirty="0" spc="0" kern="0">
+              <a:rPr lang="en-US" sz="6900" dirty="0" spc="-1" kern="0">
                 <a:solidFill>
                   <a:srgbClr val="14161C"/>
                 </a:solidFill>
@@ -14959,10 +14959,10 @@
                 <a:ea typeface="Bricolage Grotesque ExtraBold" pitchFamily="34" charset="-122"/>
                 <a:cs typeface="Bricolage Grotesque ExtraBold" pitchFamily="34" charset="-120"/>
               </a:rPr>
-              <a:t> cuộc</a:t>
-            </a:r>
-            <a:r>
-              <a:rPr lang="en-US" sz="5100" dirty="0" spc="-5" kern="0">
+              <a:t> chạm</a:t>
+            </a:r>
+            <a:r>
+              <a:rPr lang="en-US" sz="6900" dirty="0" spc="-2" kern="0">
                 <a:solidFill>
                   <a:srgbClr val="14161C"/>
                 </a:solidFill>
@@ -14970,10 +14970,10 @@
                 <a:ea typeface="Bricolage Grotesque ExtraBold" pitchFamily="34" charset="-122"/>
                 <a:cs typeface="Bricolage Grotesque ExtraBold" pitchFamily="34" charset="-120"/>
               </a:rPr>
-              <a:t> An–Bình</a:t>
-            </a:r>
-            <a:r>
-              <a:rPr lang="en-US" sz="5100" dirty="0" spc="-1" kern="0">
+              <a:t> mấy</a:t>
+            </a:r>
+            <a:r>
+              <a:rPr lang="en-US" sz="6900" dirty="0" spc="-9" kern="0">
                 <a:solidFill>
                   <a:srgbClr val="14161C"/>
                 </a:solidFill>
@@ -14981,31 +14981,9 @@
                 <a:ea typeface="Bricolage Grotesque ExtraBold" pitchFamily="34" charset="-122"/>
                 <a:cs typeface="Bricolage Grotesque ExtraBold" pitchFamily="34" charset="-120"/>
               </a:rPr>
-              <a:t> chạm</a:t>
-            </a:r>
-            <a:r>
-              <a:rPr lang="en-US" sz="5100" dirty="0" spc="-3" kern="0">
-                <a:solidFill>
-                  <a:srgbClr val="14161C"/>
-                </a:solidFill>
-                <a:latin typeface="Bricolage Grotesque ExtraBold" pitchFamily="34" charset="0"/>
-                <a:ea typeface="Bricolage Grotesque ExtraBold" pitchFamily="34" charset="-122"/>
-                <a:cs typeface="Bricolage Grotesque ExtraBold" pitchFamily="34" charset="-120"/>
-              </a:rPr>
-              <a:t> mấy</a:t>
-            </a:r>
-            <a:r>
-              <a:rPr lang="en-US" sz="5100" dirty="0" spc="-7" kern="0">
-                <a:solidFill>
-                  <a:srgbClr val="14161C"/>
-                </a:solidFill>
-                <a:latin typeface="Bricolage Grotesque ExtraBold" pitchFamily="34" charset="0"/>
-                <a:ea typeface="Bricolage Grotesque ExtraBold" pitchFamily="34" charset="-122"/>
-                <a:cs typeface="Bricolage Grotesque ExtraBold" pitchFamily="34" charset="-120"/>
-              </a:rPr>
               <a:t> shard?</a:t>
             </a:r>
-            <a:endParaRPr lang="en-US" sz="5100" dirty="0"/>
+            <a:endParaRPr lang="en-US" sz="6900" dirty="0"/>
           </a:p>
         </p:txBody>
       </p:sp>
@@ -16448,7 +16426,7 @@
               <a:buNone/>
             </a:pPr>
             <a:r>
-              <a:rPr lang="en-US" sz="6000" dirty="0" spc="-1" kern="0">
+              <a:rPr lang="en-US" sz="6900" dirty="0" spc="-1" kern="0">
                 <a:solidFill>
                   <a:srgbClr val="14161C"/>
                 </a:solidFill>
@@ -16459,7 +16437,7 @@
               <a:t>Bốn</a:t>
             </a:r>
             <a:r>
-              <a:rPr lang="en-US" sz="6000" dirty="0" spc="0" kern="0">
+              <a:rPr lang="en-US" sz="6900" dirty="0" spc="0" kern="0">
                 <a:solidFill>
                   <a:srgbClr val="14161C"/>
                 </a:solidFill>
@@ -16470,7 +16448,7 @@
               <a:t> con</a:t>
             </a:r>
             <a:r>
-              <a:rPr lang="en-US" sz="6000" dirty="0" spc="3" kern="0">
+              <a:rPr lang="en-US" sz="6900" dirty="0" spc="1" kern="0">
                 <a:solidFill>
                   <a:srgbClr val="14161C"/>
                 </a:solidFill>
@@ -16481,7 +16459,7 @@
               <a:t> số</a:t>
             </a:r>
             <a:r>
-              <a:rPr lang="en-US" sz="6000" dirty="0" spc="2" kern="0">
+              <a:rPr lang="en-US" sz="6900" dirty="0" spc="0" kern="0">
                 <a:solidFill>
                   <a:srgbClr val="14161C"/>
                 </a:solidFill>
@@ -16492,7 +16470,7 @@
               <a:t> mà</a:t>
             </a:r>
             <a:r>
-              <a:rPr lang="en-US" sz="6000" dirty="0" spc="-1" kern="0">
+              <a:rPr lang="en-US" sz="6900" dirty="0" spc="-2" kern="0">
                 <a:solidFill>
                   <a:srgbClr val="14161C"/>
                 </a:solidFill>
@@ -16503,7 +16481,7 @@
               <a:t> mã</a:t>
             </a:r>
             <a:r>
-              <a:rPr lang="en-US" sz="6000" dirty="0" spc="3" kern="0">
+              <a:rPr lang="en-US" sz="6900" dirty="0" spc="7" kern="0">
                 <a:solidFill>
                   <a:srgbClr val="14161C"/>
                 </a:solidFill>
@@ -16514,7 +16492,7 @@
               <a:t> phép</a:t>
             </a:r>
             <a:r>
-              <a:rPr lang="en-US" sz="6000" dirty="0" spc="-2" kern="0">
+              <a:rPr lang="en-US" sz="6900" dirty="0" spc="0" kern="0">
                 <a:solidFill>
                   <a:srgbClr val="14161C"/>
                 </a:solidFill>
@@ -16525,7 +16503,7 @@
               <a:t> thử</a:t>
             </a:r>
             <a:r>
-              <a:rPr lang="en-US" sz="6000" dirty="0" spc="3" kern="0">
+              <a:rPr lang="en-US" sz="6900" dirty="0" spc="2" kern="0">
                 <a:solidFill>
                   <a:srgbClr val="14161C"/>
                 </a:solidFill>
@@ -16536,7 +16514,7 @@
               <a:t> in</a:t>
             </a:r>
             <a:r>
-              <a:rPr lang="en-US" sz="6000" dirty="0" spc="-34" kern="0">
+              <a:rPr lang="en-US" sz="6900" dirty="0" spc="-41" kern="0">
                 <a:solidFill>
                   <a:srgbClr val="14161C"/>
                 </a:solidFill>
@@ -16546,7 +16524,7 @@
               </a:rPr>
               <a:t> ra</a:t>
             </a:r>
-            <a:endParaRPr lang="en-US" sz="6000" dirty="0"/>
+            <a:endParaRPr lang="en-US" sz="6900" dirty="0"/>
           </a:p>
         </p:txBody>
       </p:sp>

</xml_diff>

<commit_message>
Slides: badged PPTX of sd-04-036
</commit_message>
<xml_diff>
--- a/system-design-101/vi/lessons/sd-04-036/slides/sd-04-036.pptx
+++ b/system-design-101/vi/lessons/sd-04-036/slides/sd-04-036.pptx
@@ -2831,7 +2831,7 @@
               <a:t> · khóa</a:t>
             </a:r>
             <a:r>
-              <a:rPr lang="en-US" sz="1800" dirty="0" spc="-10" kern="0">
+              <a:rPr lang="en-US" sz="1800" dirty="0" spc="0" kern="0">
                 <a:solidFill>
                   <a:srgbClr val="9AA0B5"/>
                 </a:solidFill>
@@ -2839,10 +2839,10 @@
                 <a:ea typeface="Be Vietnam Pro" pitchFamily="34" charset="-122"/>
                 <a:cs typeface="Be Vietnam Pro" pitchFamily="34" charset="-120"/>
               </a:rPr>
-              <a:t> shard</a:t>
-            </a:r>
-            <a:r>
-              <a:rPr lang="en-US" sz="1800" dirty="0" spc="0" kern="0">
+              <a:t> là</a:t>
+            </a:r>
+            <a:r>
+              <a:rPr lang="en-US" sz="1800" dirty="0" spc="-2" kern="0">
                 <a:solidFill>
                   <a:srgbClr val="9AA0B5"/>
                 </a:solidFill>
@@ -2850,21 +2850,10 @@
                 <a:ea typeface="Be Vietnam Pro" pitchFamily="34" charset="-122"/>
                 <a:cs typeface="Be Vietnam Pro" pitchFamily="34" charset="-120"/>
               </a:rPr>
-              <a:t> là</a:t>
-            </a:r>
-            <a:r>
-              <a:rPr lang="en-US" sz="1800" dirty="0" spc="-1" kern="0">
-                <a:solidFill>
-                  <a:srgbClr val="9AA0B5"/>
-                </a:solidFill>
-                <a:latin typeface="Be Vietnam Pro" pitchFamily="34" charset="0"/>
-                <a:ea typeface="Be Vietnam Pro" pitchFamily="34" charset="-122"/>
-                <a:cs typeface="Be Vietnam Pro" pitchFamily="34" charset="-120"/>
-              </a:rPr>
               <a:t> mã</a:t>
             </a:r>
             <a:r>
-              <a:rPr lang="en-US" sz="1800" dirty="0" spc="0" kern="0">
+              <a:rPr lang="en-US" sz="1800" dirty="0" spc="1" kern="0">
                 <a:solidFill>
                   <a:srgbClr val="9AA0B5"/>
                 </a:solidFill>
@@ -7119,7 +7108,7 @@
               <a:buNone/>
             </a:pPr>
             <a:r>
-              <a:rPr lang="en-US" sz="1950" b="1" dirty="0" spc="4" kern="0">
+              <a:rPr lang="en-US" sz="1950" b="1" dirty="0" spc="0" kern="0">
                 <a:solidFill>
                   <a:srgbClr val="14161C"/>
                 </a:solidFill>
@@ -7127,10 +7116,10 @@
                 <a:ea typeface="Be Vietnam Pro" pitchFamily="34" charset="-122"/>
                 <a:cs typeface="Be Vietnam Pro" pitchFamily="34" charset="-120"/>
               </a:rPr>
-              <a:t>Đơn</a:t>
-            </a:r>
-            <a:r>
-              <a:rPr lang="en-US" sz="1950" b="1" dirty="0" spc="-2" kern="0">
+              <a:t>Khách</a:t>
+            </a:r>
+            <a:r>
+              <a:rPr lang="en-US" sz="1950" b="1" dirty="0" spc="-6" kern="0">
                 <a:solidFill>
                   <a:srgbClr val="14161C"/>
                 </a:solidFill>
@@ -7138,7 +7127,51 @@
                 <a:ea typeface="Be Vietnam Pro" pitchFamily="34" charset="-122"/>
                 <a:cs typeface="Be Vietnam Pro" pitchFamily="34" charset="-120"/>
               </a:rPr>
-              <a:t> của</a:t>
+              <a:t> 42</a:t>
+            </a:r>
+            <a:r>
+              <a:rPr lang="en-US" sz="1950" b="1" dirty="0" spc="-4" kern="0">
+                <a:solidFill>
+                  <a:srgbClr val="14161C"/>
+                </a:solidFill>
+                <a:latin typeface="Be Vietnam Pro" pitchFamily="34" charset="0"/>
+                <a:ea typeface="Be Vietnam Pro" pitchFamily="34" charset="-122"/>
+                <a:cs typeface="Be Vietnam Pro" pitchFamily="34" charset="-120"/>
+              </a:rPr>
+              <a:t> ·</a:t>
+            </a:r>
+            <a:r>
+              <a:rPr lang="en-US" sz="1950" b="1" dirty="0" spc="-6" kern="0">
+                <a:solidFill>
+                  <a:srgbClr val="14161C"/>
+                </a:solidFill>
+                <a:latin typeface="Be Vietnam Pro" pitchFamily="34" charset="0"/>
+                <a:ea typeface="Be Vietnam Pro" pitchFamily="34" charset="-122"/>
+                <a:cs typeface="Be Vietnam Pro" pitchFamily="34" charset="-120"/>
+              </a:rPr>
+              <a:t> 42</a:t>
+            </a:r>
+            <a:r>
+              <a:rPr lang="en-US" sz="1950" b="1" dirty="0" spc="-1" kern="0">
+                <a:solidFill>
+                  <a:srgbClr val="14161C"/>
+                </a:solidFill>
+                <a:latin typeface="Be Vietnam Pro" pitchFamily="34" charset="0"/>
+                <a:ea typeface="Be Vietnam Pro" pitchFamily="34" charset="-122"/>
+                <a:cs typeface="Be Vietnam Pro" pitchFamily="34" charset="-120"/>
+              </a:rPr>
+              <a:t> chia</a:t>
+            </a:r>
+            <a:r>
+              <a:rPr lang="en-US" sz="1950" b="1" dirty="0" spc="2" kern="0">
+                <a:solidFill>
+                  <a:srgbClr val="14161C"/>
+                </a:solidFill>
+                <a:latin typeface="Be Vietnam Pro" pitchFamily="34" charset="0"/>
+                <a:ea typeface="Be Vietnam Pro" pitchFamily="34" charset="-122"/>
+                <a:cs typeface="Be Vietnam Pro" pitchFamily="34" charset="-120"/>
+              </a:rPr>
+              <a:t> dư</a:t>
             </a:r>
             <a:r>
               <a:rPr lang="en-US" sz="1950" b="1" dirty="0" spc="1" kern="0">
@@ -7149,10 +7182,10 @@
                 <a:ea typeface="Be Vietnam Pro" pitchFamily="34" charset="-122"/>
                 <a:cs typeface="Be Vietnam Pro" pitchFamily="34" charset="-120"/>
               </a:rPr>
-              <a:t> khách</a:t>
-            </a:r>
-            <a:r>
-              <a:rPr lang="en-US" sz="1950" b="1" dirty="0" spc="-6" kern="0">
+              <a:t> 4</a:t>
+            </a:r>
+            <a:r>
+              <a:rPr lang="en-US" sz="1950" b="1" dirty="0" spc="2" kern="0">
                 <a:solidFill>
                   <a:srgbClr val="14161C"/>
                 </a:solidFill>
@@ -7160,65 +7193,10 @@
                 <a:ea typeface="Be Vietnam Pro" pitchFamily="34" charset="-122"/>
                 <a:cs typeface="Be Vietnam Pro" pitchFamily="34" charset="-120"/>
               </a:rPr>
-              <a:t> 42</a:t>
-            </a:r>
-            <a:r>
-              <a:rPr lang="en-US" sz="1950" b="1" dirty="0" spc="-3" kern="0">
-                <a:solidFill>
-                  <a:srgbClr val="14161C"/>
-                </a:solidFill>
-                <a:latin typeface="Be Vietnam Pro" pitchFamily="34" charset="0"/>
-                <a:ea typeface="Be Vietnam Pro" pitchFamily="34" charset="-122"/>
-                <a:cs typeface="Be Vietnam Pro" pitchFamily="34" charset="-120"/>
-              </a:rPr>
-              <a:t> ·</a:t>
-            </a:r>
-            <a:r>
-              <a:rPr lang="en-US" sz="1950" b="1" dirty="0" spc="-6" kern="0">
-                <a:solidFill>
-                  <a:srgbClr val="14161C"/>
-                </a:solidFill>
-                <a:latin typeface="Be Vietnam Pro" pitchFamily="34" charset="0"/>
-                <a:ea typeface="Be Vietnam Pro" pitchFamily="34" charset="-122"/>
-                <a:cs typeface="Be Vietnam Pro" pitchFamily="34" charset="-120"/>
-              </a:rPr>
-              <a:t> 42</a:t>
-            </a:r>
-            <a:r>
-              <a:rPr lang="en-US" sz="1950" b="1" dirty="0" spc="-1" kern="0">
-                <a:solidFill>
-                  <a:srgbClr val="14161C"/>
-                </a:solidFill>
-                <a:latin typeface="Be Vietnam Pro" pitchFamily="34" charset="0"/>
-                <a:ea typeface="Be Vietnam Pro" pitchFamily="34" charset="-122"/>
-                <a:cs typeface="Be Vietnam Pro" pitchFamily="34" charset="-120"/>
-              </a:rPr>
-              <a:t> chia</a:t>
-            </a:r>
-            <a:r>
-              <a:rPr lang="en-US" sz="1950" b="1" dirty="0" spc="2" kern="0">
-                <a:solidFill>
-                  <a:srgbClr val="14161C"/>
-                </a:solidFill>
-                <a:latin typeface="Be Vietnam Pro" pitchFamily="34" charset="0"/>
-                <a:ea typeface="Be Vietnam Pro" pitchFamily="34" charset="-122"/>
-                <a:cs typeface="Be Vietnam Pro" pitchFamily="34" charset="-120"/>
-              </a:rPr>
-              <a:t> dư 4</a:t>
-            </a:r>
-            <a:r>
-              <a:rPr lang="en-US" sz="1950" b="1" dirty="0" spc="1" kern="0">
-                <a:solidFill>
-                  <a:srgbClr val="14161C"/>
-                </a:solidFill>
-                <a:latin typeface="Be Vietnam Pro" pitchFamily="34" charset="0"/>
-                <a:ea typeface="Be Vietnam Pro" pitchFamily="34" charset="-122"/>
-                <a:cs typeface="Be Vietnam Pro" pitchFamily="34" charset="-120"/>
-              </a:rPr>
               <a:t> =</a:t>
             </a:r>
             <a:r>
-              <a:rPr lang="en-US" sz="1950" b="1" dirty="0" spc="-3" kern="0">
+              <a:rPr lang="en-US" sz="1950" b="1" dirty="0" spc="-4" kern="0">
                 <a:solidFill>
                   <a:srgbClr val="14161C"/>
                 </a:solidFill>

</xml_diff>